<commit_message>
Slides: session 18 late effects; others in progress
Co-Authored-By: Claude Opus 5.5 <noreply@anthropic.com>
Claude-Session: https://claude.ai/code/session_01XkzKv8pUGMF9AsqSCMpnBq
</commit_message>
<xml_diff>
--- a/slides/decks/s23-mds-mds-mpn.pptx
+++ b/slides/decks/s23-mds-mds-mpn.pptx
@@ -136,13 +136,13 @@
   <p:extLst>
     <p:ext uri="{521415D9-36F7-43E2-AB2F-B90AF26B5E84}">
       <p14:sectionLst xmlns:p14="http://schemas.microsoft.com/office/powerpoint/2010/main">
-        <p14:section name="Opening" id="{899a066f-94bc-38df-e7aa-8930540bfb97}">
+        <p14:section name="Opening" id="{af6ecc9a-7612-f413-11a3-9d9f88a9fe47}">
           <p14:sldIdLst>
             <p14:sldId id="256"/>
             <p14:sldId id="257"/>
           </p14:sldIdLst>
         </p14:section>
-        <p14:section name="MDS" id="{8f5e83a8-a2f2-5f31-9673-9bd9875e7286}">
+        <p14:section name="MDS" id="{81fa711c-9ee2-c5dd-5d5f-ecf6bd5a6e29}">
           <p14:sldIdLst>
             <p14:sldId id="258"/>
             <p14:sldId id="259"/>
@@ -154,7 +154,7 @@
             <p14:sldId id="265"/>
           </p14:sldIdLst>
         </p14:section>
-        <p14:section name="MDS/MPN" id="{193866f4-44aa-b129-8f6c-546cb2b44cb3}">
+        <p14:section name="MDS/MPN" id="{d23dffaa-739c-b19d-9bd3-04de136e4028}">
           <p14:sldIdLst>
             <p14:sldId id="266"/>
             <p14:sldId id="267"/>
@@ -164,7 +164,7 @@
             <p14:sldId id="271"/>
           </p14:sldIdLst>
         </p14:section>
-        <p14:section name="Board questions" id="{4808fb72-860a-185b-79c5-95fa3a19f190}">
+        <p14:section name="Board questions" id="{24ee9cdc-7f7f-9a6e-d11d-5f708a0c694b}">
           <p14:sldIdLst>
             <p14:sldId id="272"/>
             <p14:sldId id="273"/>
@@ -174,7 +174,7 @@
             <p14:sldId id="277"/>
           </p14:sldIdLst>
         </p14:section>
-        <p14:section name="References" id="{1a09b85f-fcf6-3bcb-3604-a078a0f968bc}">
+        <p14:section name="References" id="{0e34c627-1a89-4f1a-c241-19ed67ade465}">
           <p14:sldIdLst>
             <p14:sldId id="278"/>
             <p14:sldId id="279"/>
@@ -183,7 +183,7 @@
             <p14:sldId id="282"/>
           </p14:sldIdLst>
         </p14:section>
-        <p14:section name="Backup" id="{7174db05-a74a-fdae-80ce-3cb467905bc0}">
+        <p14:section name="Backup" id="{e347709f-891a-464a-35aa-6c58073c4d58}">
           <p14:sldIdLst>
             <p14:sldId id="283"/>
             <p14:sldId id="284"/>
@@ -5635,14 +5635,14 @@
                         <a:buNone/>
                       </a:pPr>
                       <a:r>
-                        <a:rPr lang="en-US" sz="1500" b="1" dirty="0">
+                        <a:rPr lang="en-US" sz="1600" b="1" dirty="0">
                           <a:solidFill>
                             <a:schemeClr val="tx1"/>
                           </a:solidFill>
                         </a:rPr>
                         <a:t>Strategy</a:t>
                       </a:r>
-                      <a:endParaRPr lang="en-US" sz="1500" dirty="0"/>
+                      <a:endParaRPr lang="en-US" sz="1600" dirty="0"/>
                     </a:p>
                   </a:txBody>
                   <a:tcPr marL="25400" marR="101600" marT="63500" marB="63500" anchor="ctr">
@@ -5681,14 +5681,14 @@
                         <a:buNone/>
                       </a:pPr>
                       <a:r>
-                        <a:rPr lang="en-US" sz="1500" b="1" dirty="0">
+                        <a:rPr lang="en-US" sz="1600" b="1" dirty="0">
                           <a:solidFill>
                             <a:schemeClr val="tx1"/>
                           </a:solidFill>
                         </a:rPr>
                         <a:t>Finding (Ch. 74)</a:t>
                       </a:r>
-                      <a:endParaRPr lang="en-US" sz="1500" dirty="0"/>
+                      <a:endParaRPr lang="en-US" sz="1600" dirty="0"/>
                     </a:p>
                   </a:txBody>
                   <a:tcPr marL="25400" marR="101600" marT="63500" marB="63500" anchor="ctr">
@@ -5729,28 +5729,28 @@
                         <a:buNone/>
                       </a:pPr>
                       <a:r>
-                        <a:rPr lang="en-US" sz="1500" dirty="0">
+                        <a:rPr lang="en-US" sz="1600" dirty="0">
                           <a:solidFill>
                             <a:schemeClr val="tx1"/>
                           </a:solidFill>
                         </a:rPr>
                         <a:t>AZA at relapse</a:t>
                       </a:r>
-                      <a:endParaRPr lang="en-US" sz="1500" dirty="0"/>
-                    </a:p>
-                    <a:p>
-                      <a:pPr indent="0" marL="0">
-                        <a:buNone/>
-                      </a:pPr>
-                      <a:r>
-                        <a:rPr lang="en-US" sz="1500" dirty="0">
+                      <a:endParaRPr lang="en-US" sz="1600" dirty="0"/>
+                    </a:p>
+                    <a:p>
+                      <a:pPr indent="0" marL="0">
+                        <a:buNone/>
+                      </a:pPr>
+                      <a:r>
+                        <a:rPr lang="en-US" sz="1600" dirty="0">
                           <a:solidFill>
                             <a:schemeClr val="tx1"/>
                           </a:solidFill>
                         </a:rPr>
                         <a:t>(Craddock 2016, n = 181)</a:t>
                       </a:r>
-                      <a:endParaRPr lang="en-US" sz="1500" dirty="0"/>
+                      <a:endParaRPr lang="en-US" sz="1600" dirty="0"/>
                     </a:p>
                   </a:txBody>
                   <a:tcPr marL="25400" marR="101600" marT="63500" marB="63500" anchor="ctr">
@@ -5783,28 +5783,28 @@
                         <a:buNone/>
                       </a:pPr>
                       <a:r>
-                        <a:rPr lang="en-US" sz="1500" dirty="0">
-                          <a:solidFill>
-                            <a:schemeClr val="tx1"/>
-                          </a:solidFill>
-                        </a:rPr>
-                        <a:t>Better with low blasts and relapse &gt; 6 months;</a:t>
-                      </a:r>
-                      <a:endParaRPr lang="en-US" sz="1500" dirty="0"/>
-                    </a:p>
-                    <a:p>
-                      <a:pPr indent="0" marL="0">
-                        <a:buNone/>
-                      </a:pPr>
-                      <a:r>
-                        <a:rPr lang="en-US" sz="1500" dirty="0">
-                          <a:solidFill>
-                            <a:schemeClr val="tx1"/>
-                          </a:solidFill>
-                        </a:rPr>
-                        <a:t>adding DLI changed nothing</a:t>
-                      </a:r>
-                      <a:endParaRPr lang="en-US" sz="1500" dirty="0"/>
+                        <a:rPr lang="en-US" sz="1600" dirty="0">
+                          <a:solidFill>
+                            <a:schemeClr val="tx1"/>
+                          </a:solidFill>
+                        </a:rPr>
+                        <a:t>Better: low blasts, relapse &gt; 6 months;</a:t>
+                      </a:r>
+                      <a:endParaRPr lang="en-US" sz="1600" dirty="0"/>
+                    </a:p>
+                    <a:p>
+                      <a:pPr indent="0" marL="0">
+                        <a:buNone/>
+                      </a:pPr>
+                      <a:r>
+                        <a:rPr lang="en-US" sz="1600" dirty="0">
+                          <a:solidFill>
+                            <a:schemeClr val="tx1"/>
+                          </a:solidFill>
+                        </a:rPr>
+                        <a:t>DLI added nothing</a:t>
+                      </a:r>
+                      <a:endParaRPr lang="en-US" sz="1600" dirty="0"/>
                     </a:p>
                   </a:txBody>
                   <a:tcPr marL="25400" marR="101600" marT="63500" marB="63500" anchor="ctr">
@@ -5839,28 +5839,28 @@
                         <a:buNone/>
                       </a:pPr>
                       <a:r>
-                        <a:rPr lang="en-US" sz="1500" dirty="0">
+                        <a:rPr lang="en-US" sz="1600" dirty="0">
                           <a:solidFill>
                             <a:schemeClr val="tx1"/>
                           </a:solidFill>
                         </a:rPr>
                         <a:t>DLI or 2nd HCT</a:t>
                       </a:r>
-                      <a:endParaRPr lang="en-US" sz="1500" dirty="0"/>
-                    </a:p>
-                    <a:p>
-                      <a:pPr indent="0" marL="0">
-                        <a:buNone/>
-                      </a:pPr>
-                      <a:r>
-                        <a:rPr lang="en-US" sz="1500" dirty="0">
+                      <a:endParaRPr lang="en-US" sz="1600" dirty="0"/>
+                    </a:p>
+                    <a:p>
+                      <a:pPr indent="0" marL="0">
+                        <a:buNone/>
+                      </a:pPr>
+                      <a:r>
+                        <a:rPr lang="en-US" sz="1600" dirty="0">
                           <a:solidFill>
                             <a:schemeClr val="tx1"/>
                           </a:solidFill>
                         </a:rPr>
                         <a:t>(Guièze 2016, n = 147)</a:t>
                       </a:r>
-                      <a:endParaRPr lang="en-US" sz="1500" dirty="0"/>
+                      <a:endParaRPr lang="en-US" sz="1600" dirty="0"/>
                     </a:p>
                   </a:txBody>
                   <a:tcPr marL="25400" marR="101600" marT="63500" marB="63500" anchor="ctr">
@@ -5893,28 +5893,28 @@
                         <a:buNone/>
                       </a:pPr>
                       <a:r>
-                        <a:rPr lang="en-US" sz="1500" dirty="0">
+                        <a:rPr lang="en-US" sz="1600" dirty="0">
                           <a:solidFill>
                             <a:schemeClr val="tx1"/>
                           </a:solidFill>
                         </a:rPr>
                         <a:t>Long-term survival 32% vs 6% with</a:t>
                       </a:r>
-                      <a:endParaRPr lang="en-US" sz="1500" dirty="0"/>
-                    </a:p>
-                    <a:p>
-                      <a:pPr indent="0" marL="0">
-                        <a:buNone/>
-                      </a:pPr>
-                      <a:r>
-                        <a:rPr lang="en-US" sz="1500" dirty="0">
+                      <a:endParaRPr lang="en-US" sz="1600" dirty="0"/>
+                    </a:p>
+                    <a:p>
+                      <a:pPr indent="0" marL="0">
+                        <a:buNone/>
+                      </a:pPr>
+                      <a:r>
+                        <a:rPr lang="en-US" sz="1600" dirty="0">
                           <a:solidFill>
                             <a:schemeClr val="tx1"/>
                           </a:solidFill>
                         </a:rPr>
                         <a:t>chemotherapy alone</a:t>
                       </a:r>
-                      <a:endParaRPr lang="en-US" sz="1500" dirty="0"/>
+                      <a:endParaRPr lang="en-US" sz="1600" dirty="0"/>
                     </a:p>
                   </a:txBody>
                   <a:tcPr marL="25400" marR="101600" marT="63500" marB="63500" anchor="ctr">
@@ -5949,28 +5949,28 @@
                         <a:buNone/>
                       </a:pPr>
                       <a:r>
-                        <a:rPr lang="en-US" sz="1500" dirty="0">
+                        <a:rPr lang="en-US" sz="1600" dirty="0">
                           <a:solidFill>
                             <a:schemeClr val="tx1"/>
                           </a:solidFill>
                         </a:rPr>
                         <a:t>2nd allo-HCT</a:t>
                       </a:r>
-                      <a:endParaRPr lang="en-US" sz="1500" dirty="0"/>
-                    </a:p>
-                    <a:p>
-                      <a:pPr indent="0" marL="0">
-                        <a:buNone/>
-                      </a:pPr>
-                      <a:r>
-                        <a:rPr lang="en-US" sz="1500" dirty="0">
+                      <a:endParaRPr lang="en-US" sz="1600" dirty="0"/>
+                    </a:p>
+                    <a:p>
+                      <a:pPr indent="0" marL="0">
+                        <a:buNone/>
+                      </a:pPr>
+                      <a:r>
+                        <a:rPr lang="en-US" sz="1600" dirty="0">
                           <a:solidFill>
                             <a:schemeClr val="tx1"/>
                           </a:solidFill>
                         </a:rPr>
                         <a:t>(Schmid 2018)</a:t>
                       </a:r>
-                      <a:endParaRPr lang="en-US" sz="1500" dirty="0"/>
+                      <a:endParaRPr lang="en-US" sz="1600" dirty="0"/>
                     </a:p>
                   </a:txBody>
                   <a:tcPr marL="25400" marR="101600" marT="63500" marB="63500" anchor="ctr">
@@ -6003,28 +6003,28 @@
                         <a:buNone/>
                       </a:pPr>
                       <a:r>
-                        <a:rPr lang="en-US" sz="1500" dirty="0">
+                        <a:rPr lang="en-US" sz="1600" dirty="0">
                           <a:solidFill>
                             <a:schemeClr val="tx1"/>
                           </a:solidFill>
                         </a:rPr>
                         <a:t>Rescues some in CR, without prior GVHD,</a:t>
                       </a:r>
-                      <a:endParaRPr lang="en-US" sz="1500" dirty="0"/>
-                    </a:p>
-                    <a:p>
-                      <a:pPr indent="0" marL="0">
-                        <a:buNone/>
-                      </a:pPr>
-                      <a:r>
-                        <a:rPr lang="en-US" sz="1500" dirty="0">
+                      <a:endParaRPr lang="en-US" sz="1600" dirty="0"/>
+                    </a:p>
+                    <a:p>
+                      <a:pPr indent="0" marL="0">
+                        <a:buNone/>
+                      </a:pPr>
+                      <a:r>
+                        <a:rPr lang="en-US" sz="1600" dirty="0">
                           <a:solidFill>
                             <a:schemeClr val="tx1"/>
                           </a:solidFill>
                         </a:rPr>
                         <a:t>with a new donor</a:t>
                       </a:r>
-                      <a:endParaRPr lang="en-US" sz="1500" dirty="0"/>
+                      <a:endParaRPr lang="en-US" sz="1600" dirty="0"/>
                     </a:p>
                   </a:txBody>
                   <a:tcPr marL="25400" marR="101600" marT="63500" marB="63500" anchor="ctr">
@@ -6059,14 +6059,14 @@
                         <a:buNone/>
                       </a:pPr>
                       <a:r>
-                        <a:rPr lang="en-US" sz="1500" dirty="0">
+                        <a:rPr lang="en-US" sz="1600" dirty="0">
                           <a:solidFill>
                             <a:schemeClr val="tx1"/>
                           </a:solidFill>
                         </a:rPr>
                         <a:t>Pre-emptive AZA or DLI</a:t>
                       </a:r>
-                      <a:endParaRPr lang="en-US" sz="1500" dirty="0"/>
+                      <a:endParaRPr lang="en-US" sz="1600" dirty="0"/>
                     </a:p>
                   </a:txBody>
                   <a:tcPr marL="25400" marR="101600" marT="63500" marB="63500" anchor="ctr">
@@ -6099,14 +6099,14 @@
                         <a:buNone/>
                       </a:pPr>
                       <a:r>
-                        <a:rPr lang="en-US" sz="1500" dirty="0">
+                        <a:rPr lang="en-US" sz="1600" dirty="0">
                           <a:solidFill>
                             <a:schemeClr val="tx1"/>
                           </a:solidFill>
                         </a:rPr>
                         <a:t>Risk- or MRD-guided: biallelic TP53, complex karyotype</a:t>
                       </a:r>
-                      <a:endParaRPr lang="en-US" sz="1500" dirty="0"/>
+                      <a:endParaRPr lang="en-US" sz="1600" dirty="0"/>
                     </a:p>
                   </a:txBody>
                   <a:tcPr marL="25400" marR="101600" marT="63500" marB="63500" anchor="ctr">
@@ -6141,28 +6141,28 @@
                         <a:buNone/>
                       </a:pPr>
                       <a:r>
-                        <a:rPr lang="en-US" sz="1500" dirty="0">
+                        <a:rPr lang="en-US" sz="1600" dirty="0">
                           <a:solidFill>
                             <a:schemeClr val="tx1"/>
                           </a:solidFill>
                         </a:rPr>
                         <a:t>HMA prophylaxis meta-analysis</a:t>
                       </a:r>
-                      <a:endParaRPr lang="en-US" sz="1500" dirty="0"/>
-                    </a:p>
-                    <a:p>
-                      <a:pPr indent="0" marL="0">
-                        <a:buNone/>
-                      </a:pPr>
-                      <a:r>
-                        <a:rPr lang="en-US" sz="1500" dirty="0">
+                      <a:endParaRPr lang="en-US" sz="1600" dirty="0"/>
+                    </a:p>
+                    <a:p>
+                      <a:pPr indent="0" marL="0">
+                        <a:buNone/>
+                      </a:pPr>
+                      <a:r>
+                        <a:rPr lang="en-US" sz="1600" dirty="0">
                           <a:solidFill>
                             <a:schemeClr val="tx1"/>
                           </a:solidFill>
                         </a:rPr>
                         <a:t>(Kungwankiattichai 2022)</a:t>
                       </a:r>
-                      <a:endParaRPr lang="en-US" sz="1500" dirty="0"/>
+                      <a:endParaRPr lang="en-US" sz="1600" dirty="0"/>
                     </a:p>
                   </a:txBody>
                   <a:tcPr marL="25400" marR="101600" marT="63500" marB="63500" anchor="ctr">
@@ -6195,14 +6195,14 @@
                         <a:buNone/>
                       </a:pPr>
                       <a:r>
-                        <a:rPr lang="en-US" sz="1500" dirty="0">
+                        <a:rPr lang="en-US" sz="1600" dirty="0">
                           <a:solidFill>
                             <a:schemeClr val="tx1"/>
                           </a:solidFill>
                         </a:rPr>
                         <a:t>Better survival</a:t>
                       </a:r>
-                      <a:endParaRPr lang="en-US" sz="1500" dirty="0"/>
+                      <a:endParaRPr lang="en-US" sz="1600" dirty="0"/>
                     </a:p>
                   </a:txBody>
                   <a:tcPr marL="25400" marR="101600" marT="63500" marB="63500" anchor="ctr">
@@ -6237,28 +6237,28 @@
                         <a:buNone/>
                       </a:pPr>
                       <a:r>
-                        <a:rPr lang="en-US" sz="1500" dirty="0">
+                        <a:rPr lang="en-US" sz="1600" dirty="0">
                           <a:solidFill>
                             <a:schemeClr val="tx1"/>
                           </a:solidFill>
                         </a:rPr>
                         <a:t>AZA maintenance phase 3</a:t>
                       </a:r>
-                      <a:endParaRPr lang="en-US" sz="1500" dirty="0"/>
-                    </a:p>
-                    <a:p>
-                      <a:pPr indent="0" marL="0">
-                        <a:buNone/>
-                      </a:pPr>
-                      <a:r>
-                        <a:rPr lang="en-US" sz="1500" dirty="0">
+                      <a:endParaRPr lang="en-US" sz="1600" dirty="0"/>
+                    </a:p>
+                    <a:p>
+                      <a:pPr indent="0" marL="0">
+                        <a:buNone/>
+                      </a:pPr>
+                      <a:r>
+                        <a:rPr lang="en-US" sz="1600" dirty="0">
                           <a:solidFill>
                             <a:schemeClr val="tx1"/>
                           </a:solidFill>
                         </a:rPr>
                         <a:t>(Oran 2020)</a:t>
                       </a:r>
-                      <a:endParaRPr lang="en-US" sz="1500" dirty="0"/>
+                      <a:endParaRPr lang="en-US" sz="1600" dirty="0"/>
                     </a:p>
                   </a:txBody>
                   <a:tcPr marL="25400" marR="101600" marT="63500" marB="63500" anchor="ctr">
@@ -6291,14 +6291,14 @@
                         <a:buNone/>
                       </a:pPr>
                       <a:r>
-                        <a:rPr lang="en-US" sz="1500" dirty="0">
+                        <a:rPr lang="en-US" sz="1600" dirty="0">
                           <a:solidFill>
                             <a:schemeClr val="tx1"/>
                           </a:solidFill>
                         </a:rPr>
                         <a:t>No benefit over observation</a:t>
                       </a:r>
-                      <a:endParaRPr lang="en-US" sz="1500" dirty="0"/>
+                      <a:endParaRPr lang="en-US" sz="1600" dirty="0"/>
                     </a:p>
                   </a:txBody>
                   <a:tcPr marL="25400" marR="101600" marT="63500" marB="63500" anchor="ctr">
@@ -7860,7 +7860,7 @@
                             <a:schemeClr val="tx1"/>
                           </a:solidFill>
                         </a:rPr>
-                        <a:t>CMML karyotype int/high [1/2]; TD [1]</a:t>
+                        <a:t>karyotype int/high [1/2]; TD [1]</a:t>
                       </a:r>
                       <a:endParaRPr lang="en-US" sz="1600" dirty="0"/>
                     </a:p>
@@ -8010,7 +8010,7 @@
                             <a:schemeClr val="tx1"/>
                           </a:solidFill>
                         </a:rPr>
-                        <a:t>WBC ≥ 13 [1]; BM blasts ≥ 5% [1];</a:t>
+                        <a:t>WBC ≥ 13 [1]; marrow blasts ≥ 5% [1];</a:t>
                       </a:r>
                       <a:endParaRPr lang="en-US" sz="1600" dirty="0"/>
                     </a:p>
@@ -8024,7 +8024,7 @@
                             <a:schemeClr val="tx1"/>
                           </a:solidFill>
                         </a:rPr>
-                        <a:t>genetic risk group [0–3]; TD [1]</a:t>
+                        <a:t>genetic risk [0–3]; TD [1]</a:t>
                       </a:r>
                       <a:endParaRPr lang="en-US" sz="1600" dirty="0"/>
                     </a:p>
@@ -8160,7 +8160,7 @@
                             <a:schemeClr val="tx1"/>
                           </a:solidFill>
                         </a:rPr>
-                        <a:t>Low: normal, isolated −Y;</a:t>
+                        <a:t>Low: normal, −Y alone; high: +8,</a:t>
                       </a:r>
                       <a:endParaRPr lang="en-US" sz="1600" dirty="0"/>
                     </a:p>
@@ -8174,7 +8174,7 @@
                             <a:schemeClr val="tx1"/>
                           </a:solidFill>
                         </a:rPr>
-                        <a:t>high: +8, complex (≥ 3), chromosome 7</a:t>
+                        <a:t>complex (≥ 3), chromosome 7</a:t>
                       </a:r>
                       <a:endParaRPr lang="en-US" sz="1600" dirty="0"/>
                     </a:p>
@@ -8638,14 +8638,14 @@
                         <a:buNone/>
                       </a:pPr>
                       <a:r>
-                        <a:rPr lang="en-US" sz="1500" b="1" dirty="0">
+                        <a:rPr lang="en-US" sz="1600" b="1" dirty="0">
                           <a:solidFill>
                             <a:schemeClr val="tx1"/>
                           </a:solidFill>
                         </a:rPr>
                         <a:t>Entity · model</a:t>
                       </a:r>
-                      <a:endParaRPr lang="en-US" sz="1500" dirty="0"/>
+                      <a:endParaRPr lang="en-US" sz="1600" dirty="0"/>
                     </a:p>
                   </a:txBody>
                   <a:tcPr marL="25400" marR="101600" marT="63500" marB="63500" anchor="ctr">
@@ -8684,14 +8684,14 @@
                         <a:buNone/>
                       </a:pPr>
                       <a:r>
-                        <a:rPr lang="en-US" sz="1500" b="1" dirty="0">
+                        <a:rPr lang="en-US" sz="1600" b="1" dirty="0">
                           <a:solidFill>
                             <a:schemeClr val="tx1"/>
                           </a:solidFill>
                         </a:rPr>
                         <a:t>Variables [points]</a:t>
                       </a:r>
-                      <a:endParaRPr lang="en-US" sz="1500" dirty="0"/>
+                      <a:endParaRPr lang="en-US" sz="1600" dirty="0"/>
                     </a:p>
                   </a:txBody>
                   <a:tcPr marL="25400" marR="101600" marT="63500" marB="63500" anchor="ctr">
@@ -8730,14 +8730,14 @@
                         <a:buNone/>
                       </a:pPr>
                       <a:r>
-                        <a:rPr lang="en-US" sz="1500" b="1" dirty="0">
+                        <a:rPr lang="en-US" sz="1600" b="1" dirty="0">
                           <a:solidFill>
                             <a:schemeClr val="tx1"/>
                           </a:solidFill>
                         </a:rPr>
                         <a:t>Score (median OS, months)</a:t>
                       </a:r>
-                      <a:endParaRPr lang="en-US" sz="1500" dirty="0"/>
+                      <a:endParaRPr lang="en-US" sz="1600" dirty="0"/>
                     </a:p>
                   </a:txBody>
                   <a:tcPr marL="25400" marR="101600" marT="63500" marB="63500" anchor="ctr">
@@ -8778,28 +8778,28 @@
                         <a:buNone/>
                       </a:pPr>
                       <a:r>
-                        <a:rPr lang="en-US" sz="1500" dirty="0">
+                        <a:rPr lang="en-US" sz="1600" dirty="0">
                           <a:solidFill>
                             <a:schemeClr val="tx1"/>
                           </a:solidFill>
                         </a:rPr>
                         <a:t>CMML · GFM</a:t>
                       </a:r>
-                      <a:endParaRPr lang="en-US" sz="1500" dirty="0"/>
-                    </a:p>
-                    <a:p>
-                      <a:pPr indent="0" marL="0">
-                        <a:buNone/>
-                      </a:pPr>
-                      <a:r>
-                        <a:rPr lang="en-US" sz="1500" dirty="0">
+                      <a:endParaRPr lang="en-US" sz="1600" dirty="0"/>
+                    </a:p>
+                    <a:p>
+                      <a:pPr indent="0" marL="0">
+                        <a:buNone/>
+                      </a:pPr>
+                      <a:r>
+                        <a:rPr lang="en-US" sz="1600" dirty="0">
                           <a:solidFill>
                             <a:schemeClr val="tx1"/>
                           </a:solidFill>
                         </a:rPr>
                         <a:t>(Itzykson 2013)</a:t>
                       </a:r>
-                      <a:endParaRPr lang="en-US" sz="1500" dirty="0"/>
+                      <a:endParaRPr lang="en-US" sz="1600" dirty="0"/>
                     </a:p>
                   </a:txBody>
                   <a:tcPr marL="25400" marR="101600" marT="63500" marB="63500" anchor="ctr">
@@ -8832,28 +8832,28 @@
                         <a:buNone/>
                       </a:pPr>
                       <a:r>
-                        <a:rPr lang="en-US" sz="1500" dirty="0">
-                          <a:solidFill>
-                            <a:schemeClr val="tx1"/>
-                          </a:solidFill>
-                        </a:rPr>
-                        <a:t>Age &gt; 65 [2]; WBC &gt; 15 [3]; PLT &lt; 100 [2];</a:t>
-                      </a:r>
-                      <a:endParaRPr lang="en-US" sz="1500" dirty="0"/>
-                    </a:p>
-                    <a:p>
-                      <a:pPr indent="0" marL="0">
-                        <a:buNone/>
-                      </a:pPr>
-                      <a:r>
-                        <a:rPr lang="en-US" sz="1500" dirty="0">
-                          <a:solidFill>
-                            <a:schemeClr val="tx1"/>
-                          </a:solidFill>
-                        </a:rPr>
-                        <a:t>anaemia [2]; ASXL1 [2]</a:t>
-                      </a:r>
-                      <a:endParaRPr lang="en-US" sz="1500" dirty="0"/>
+                        <a:rPr lang="en-US" sz="1600" dirty="0">
+                          <a:solidFill>
+                            <a:schemeClr val="tx1"/>
+                          </a:solidFill>
+                        </a:rPr>
+                        <a:t>[2]: age &gt; 65, PLT &lt; 100, anaemia, ASXL1;</a:t>
+                      </a:r>
+                      <a:endParaRPr lang="en-US" sz="1600" dirty="0"/>
+                    </a:p>
+                    <a:p>
+                      <a:pPr indent="0" marL="0">
+                        <a:buNone/>
+                      </a:pPr>
+                      <a:r>
+                        <a:rPr lang="en-US" sz="1600" dirty="0">
+                          <a:solidFill>
+                            <a:schemeClr val="tx1"/>
+                          </a:solidFill>
+                        </a:rPr>
+                        <a:t>[3]: WBC &gt; 15</a:t>
+                      </a:r>
+                      <a:endParaRPr lang="en-US" sz="1600" dirty="0"/>
                     </a:p>
                   </a:txBody>
                   <a:tcPr marL="25400" marR="101600" marT="63500" marB="63500" anchor="ctr">
@@ -8886,28 +8886,28 @@
                         <a:buNone/>
                       </a:pPr>
                       <a:r>
-                        <a:rPr lang="en-US" sz="1500" dirty="0">
+                        <a:rPr lang="en-US" sz="1600" dirty="0">
                           <a:solidFill>
                             <a:schemeClr val="tx1"/>
                           </a:solidFill>
                         </a:rPr>
                         <a:t>Low ≤ 4 (NR); int 5–7 (38.5);</a:t>
                       </a:r>
-                      <a:endParaRPr lang="en-US" sz="1500" dirty="0"/>
-                    </a:p>
-                    <a:p>
-                      <a:pPr indent="0" marL="0">
-                        <a:buNone/>
-                      </a:pPr>
-                      <a:r>
-                        <a:rPr lang="en-US" sz="1500" dirty="0">
+                      <a:endParaRPr lang="en-US" sz="1600" dirty="0"/>
+                    </a:p>
+                    <a:p>
+                      <a:pPr indent="0" marL="0">
+                        <a:buNone/>
+                      </a:pPr>
+                      <a:r>
+                        <a:rPr lang="en-US" sz="1600" dirty="0">
                           <a:solidFill>
                             <a:schemeClr val="tx1"/>
                           </a:solidFill>
                         </a:rPr>
                         <a:t>high ≥ 8 (14.4)</a:t>
                       </a:r>
-                      <a:endParaRPr lang="en-US" sz="1500" dirty="0"/>
+                      <a:endParaRPr lang="en-US" sz="1600" dirty="0"/>
                     </a:p>
                   </a:txBody>
                   <a:tcPr marL="25400" marR="101600" marT="63500" marB="63500" anchor="ctr">
@@ -8942,28 +8942,28 @@
                         <a:buNone/>
                       </a:pPr>
                       <a:r>
-                        <a:rPr lang="en-US" sz="1500" dirty="0">
+                        <a:rPr lang="en-US" sz="1600" dirty="0">
                           <a:solidFill>
                             <a:schemeClr val="tx1"/>
                           </a:solidFill>
                         </a:rPr>
                         <a:t>CMML · MMM</a:t>
                       </a:r>
-                      <a:endParaRPr lang="en-US" sz="1500" dirty="0"/>
-                    </a:p>
-                    <a:p>
-                      <a:pPr indent="0" marL="0">
-                        <a:buNone/>
-                      </a:pPr>
-                      <a:r>
-                        <a:rPr lang="en-US" sz="1500" dirty="0">
+                      <a:endParaRPr lang="en-US" sz="1600" dirty="0"/>
+                    </a:p>
+                    <a:p>
+                      <a:pPr indent="0" marL="0">
+                        <a:buNone/>
+                      </a:pPr>
+                      <a:r>
+                        <a:rPr lang="en-US" sz="1600" dirty="0">
                           <a:solidFill>
                             <a:schemeClr val="tx1"/>
                           </a:solidFill>
                         </a:rPr>
                         <a:t>(Patnaik 2014)</a:t>
                       </a:r>
-                      <a:endParaRPr lang="en-US" sz="1500" dirty="0"/>
+                      <a:endParaRPr lang="en-US" sz="1600" dirty="0"/>
                     </a:p>
                   </a:txBody>
                   <a:tcPr marL="25400" marR="101600" marT="63500" marB="63500" anchor="ctr">
@@ -8996,28 +8996,28 @@
                         <a:buNone/>
                       </a:pPr>
                       <a:r>
-                        <a:rPr lang="en-US" sz="1500" dirty="0">
-                          <a:solidFill>
-                            <a:schemeClr val="tx1"/>
-                          </a:solidFill>
-                        </a:rPr>
-                        <a:t>Hb &lt; 10 [2]; AMC &gt; 10 [2]; IMC &gt; 0% [2];</a:t>
-                      </a:r>
-                      <a:endParaRPr lang="en-US" sz="1500" dirty="0"/>
-                    </a:p>
-                    <a:p>
-                      <a:pPr indent="0" marL="0">
-                        <a:buNone/>
-                      </a:pPr>
-                      <a:r>
-                        <a:rPr lang="en-US" sz="1500" dirty="0">
-                          <a:solidFill>
-                            <a:schemeClr val="tx1"/>
-                          </a:solidFill>
-                        </a:rPr>
-                        <a:t>PLT &lt; 100 [1.5]; ASXL1 [1.5]</a:t>
-                      </a:r>
-                      <a:endParaRPr lang="en-US" sz="1500" dirty="0"/>
+                        <a:rPr lang="en-US" sz="1600" dirty="0">
+                          <a:solidFill>
+                            <a:schemeClr val="tx1"/>
+                          </a:solidFill>
+                        </a:rPr>
+                        <a:t>[2]: Hb &lt; 10, AMC &gt; 10, IMC &gt; 0%;</a:t>
+                      </a:r>
+                      <a:endParaRPr lang="en-US" sz="1600" dirty="0"/>
+                    </a:p>
+                    <a:p>
+                      <a:pPr indent="0" marL="0">
+                        <a:buNone/>
+                      </a:pPr>
+                      <a:r>
+                        <a:rPr lang="en-US" sz="1600" dirty="0">
+                          <a:solidFill>
+                            <a:schemeClr val="tx1"/>
+                          </a:solidFill>
+                        </a:rPr>
+                        <a:t>[1.5]: PLT &lt; 100, ASXL1</a:t>
+                      </a:r>
+                      <a:endParaRPr lang="en-US" sz="1600" dirty="0"/>
                     </a:p>
                   </a:txBody>
                   <a:tcPr marL="25400" marR="101600" marT="63500" marB="63500" anchor="ctr">
@@ -9050,28 +9050,28 @@
                         <a:buNone/>
                       </a:pPr>
                       <a:r>
-                        <a:rPr lang="en-US" sz="1500" dirty="0">
-                          <a:solidFill>
-                            <a:schemeClr val="tx1"/>
-                          </a:solidFill>
-                        </a:rPr>
-                        <a:t>Low 0 (97); int-1 1.5–2 (59);</a:t>
-                      </a:r>
-                      <a:endParaRPr lang="en-US" sz="1500" dirty="0"/>
-                    </a:p>
-                    <a:p>
-                      <a:pPr indent="0" marL="0">
-                        <a:buNone/>
-                      </a:pPr>
-                      <a:r>
-                        <a:rPr lang="en-US" sz="1500" dirty="0">
-                          <a:solidFill>
-                            <a:schemeClr val="tx1"/>
-                          </a:solidFill>
-                        </a:rPr>
-                        <a:t>int-2 2.5–4.5 (31); high ≥ 5 (16)</a:t>
-                      </a:r>
-                      <a:endParaRPr lang="en-US" sz="1500" dirty="0"/>
+                        <a:rPr lang="en-US" sz="1600" dirty="0">
+                          <a:solidFill>
+                            <a:schemeClr val="tx1"/>
+                          </a:solidFill>
+                        </a:rPr>
+                        <a:t>Low 0 (97); I-1 1.5–2 (59);</a:t>
+                      </a:r>
+                      <a:endParaRPr lang="en-US" sz="1600" dirty="0"/>
+                    </a:p>
+                    <a:p>
+                      <a:pPr indent="0" marL="0">
+                        <a:buNone/>
+                      </a:pPr>
+                      <a:r>
+                        <a:rPr lang="en-US" sz="1600" dirty="0">
+                          <a:solidFill>
+                            <a:schemeClr val="tx1"/>
+                          </a:solidFill>
+                        </a:rPr>
+                        <a:t>I-2 2.5–4.5 (31); high ≥ 5 (16)</a:t>
+                      </a:r>
+                      <a:endParaRPr lang="en-US" sz="1600" dirty="0"/>
                     </a:p>
                   </a:txBody>
                   <a:tcPr marL="25400" marR="101600" marT="63500" marB="63500" anchor="ctr">
@@ -9106,28 +9106,28 @@
                         <a:buNone/>
                       </a:pPr>
                       <a:r>
-                        <a:rPr lang="en-US" sz="1500" dirty="0">
+                        <a:rPr lang="en-US" sz="1600" dirty="0">
                           <a:solidFill>
                             <a:schemeClr val="tx1"/>
                           </a:solidFill>
                         </a:rPr>
                         <a:t>MDS/MPN-N · MDACC</a:t>
                       </a:r>
-                      <a:endParaRPr lang="en-US" sz="1500" dirty="0"/>
-                    </a:p>
-                    <a:p>
-                      <a:pPr indent="0" marL="0">
-                        <a:buNone/>
-                      </a:pPr>
-                      <a:r>
-                        <a:rPr lang="en-US" sz="1500" dirty="0">
+                      <a:endParaRPr lang="en-US" sz="1600" dirty="0"/>
+                    </a:p>
+                    <a:p>
+                      <a:pPr indent="0" marL="0">
+                        <a:buNone/>
+                      </a:pPr>
+                      <a:r>
+                        <a:rPr lang="en-US" sz="1600" dirty="0">
                           <a:solidFill>
                             <a:schemeClr val="tx1"/>
                           </a:solidFill>
                         </a:rPr>
                         <a:t>(Onida 2002)</a:t>
                       </a:r>
-                      <a:endParaRPr lang="en-US" sz="1500" dirty="0"/>
+                      <a:endParaRPr lang="en-US" sz="1600" dirty="0"/>
                     </a:p>
                   </a:txBody>
                   <a:tcPr marL="25400" marR="101600" marT="63500" marB="63500" anchor="ctr">
@@ -9160,28 +9160,28 @@
                         <a:buNone/>
                       </a:pPr>
                       <a:r>
-                        <a:rPr lang="en-US" sz="1500" dirty="0">
+                        <a:rPr lang="en-US" sz="1600" dirty="0">
                           <a:solidFill>
                             <a:schemeClr val="tx1"/>
                           </a:solidFill>
                         </a:rPr>
                         <a:t>Age &gt; 65 [1]; Hb ≤ 10 [1];</a:t>
                       </a:r>
-                      <a:endParaRPr lang="en-US" sz="1500" dirty="0"/>
-                    </a:p>
-                    <a:p>
-                      <a:pPr indent="0" marL="0">
-                        <a:buNone/>
-                      </a:pPr>
-                      <a:r>
-                        <a:rPr lang="en-US" sz="1500" dirty="0">
+                      <a:endParaRPr lang="en-US" sz="1600" dirty="0"/>
+                    </a:p>
+                    <a:p>
+                      <a:pPr indent="0" marL="0">
+                        <a:buNone/>
+                      </a:pPr>
+                      <a:r>
+                        <a:rPr lang="en-US" sz="1600" dirty="0">
                           <a:solidFill>
                             <a:schemeClr val="tx1"/>
                           </a:solidFill>
                         </a:rPr>
                         <a:t>WBC &gt; 50 [1]</a:t>
                       </a:r>
-                      <a:endParaRPr lang="en-US" sz="1500" dirty="0"/>
+                      <a:endParaRPr lang="en-US" sz="1600" dirty="0"/>
                     </a:p>
                   </a:txBody>
                   <a:tcPr marL="25400" marR="101600" marT="63500" marB="63500" anchor="ctr">
@@ -9214,14 +9214,14 @@
                         <a:buNone/>
                       </a:pPr>
                       <a:r>
-                        <a:rPr lang="en-US" sz="1500" dirty="0">
+                        <a:rPr lang="en-US" sz="1600" dirty="0">
                           <a:solidFill>
                             <a:schemeClr val="tx1"/>
                           </a:solidFill>
                         </a:rPr>
                         <a:t>Low 0–1 (38); high 2–3 (9)</a:t>
                       </a:r>
-                      <a:endParaRPr lang="en-US" sz="1500" dirty="0"/>
+                      <a:endParaRPr lang="en-US" sz="1600" dirty="0"/>
                     </a:p>
                   </a:txBody>
                   <a:tcPr marL="25400" marR="101600" marT="63500" marB="63500" anchor="ctr">
@@ -9256,28 +9256,28 @@
                         <a:buNone/>
                       </a:pPr>
                       <a:r>
-                        <a:rPr lang="en-US" sz="1500" dirty="0">
+                        <a:rPr lang="en-US" sz="1600" dirty="0">
                           <a:solidFill>
                             <a:schemeClr val="tx1"/>
                           </a:solidFill>
                         </a:rPr>
                         <a:t>SF3B1-T · Mayo</a:t>
                       </a:r>
-                      <a:endParaRPr lang="en-US" sz="1500" dirty="0"/>
-                    </a:p>
-                    <a:p>
-                      <a:pPr indent="0" marL="0">
-                        <a:buNone/>
-                      </a:pPr>
-                      <a:r>
-                        <a:rPr lang="en-US" sz="1500" dirty="0">
+                      <a:endParaRPr lang="en-US" sz="1600" dirty="0"/>
+                    </a:p>
+                    <a:p>
+                      <a:pPr indent="0" marL="0">
+                        <a:buNone/>
+                      </a:pPr>
+                      <a:r>
+                        <a:rPr lang="en-US" sz="1600" dirty="0">
                           <a:solidFill>
                             <a:schemeClr val="tx1"/>
                           </a:solidFill>
                         </a:rPr>
                         <a:t>(Patnaik 2016)</a:t>
                       </a:r>
-                      <a:endParaRPr lang="en-US" sz="1500" dirty="0"/>
+                      <a:endParaRPr lang="en-US" sz="1600" dirty="0"/>
                     </a:p>
                   </a:txBody>
                   <a:tcPr marL="25400" marR="101600" marT="63500" marB="63500" anchor="ctr">
@@ -9310,28 +9310,28 @@
                         <a:buNone/>
                       </a:pPr>
                       <a:r>
-                        <a:rPr lang="en-US" sz="1500" dirty="0">
+                        <a:rPr lang="en-US" sz="1600" dirty="0">
                           <a:solidFill>
                             <a:schemeClr val="tx1"/>
                           </a:solidFill>
                         </a:rPr>
                         <a:t>Hb &lt; 10 [1]; abnormal karyotype [2];</a:t>
                       </a:r>
-                      <a:endParaRPr lang="en-US" sz="1500" dirty="0"/>
-                    </a:p>
-                    <a:p>
-                      <a:pPr indent="0" marL="0">
-                        <a:buNone/>
-                      </a:pPr>
-                      <a:r>
-                        <a:rPr lang="en-US" sz="1500" dirty="0">
+                      <a:endParaRPr lang="en-US" sz="1600" dirty="0"/>
+                    </a:p>
+                    <a:p>
+                      <a:pPr indent="0" marL="0">
+                        <a:buNone/>
+                      </a:pPr>
+                      <a:r>
+                        <a:rPr lang="en-US" sz="1600" dirty="0">
                           <a:solidFill>
                             <a:schemeClr val="tx1"/>
                           </a:solidFill>
                         </a:rPr>
                         <a:t>ASXL1 [1]; SETBP1 [1]</a:t>
                       </a:r>
-                      <a:endParaRPr lang="en-US" sz="1500" dirty="0"/>
+                      <a:endParaRPr lang="en-US" sz="1600" dirty="0"/>
                     </a:p>
                   </a:txBody>
                   <a:tcPr marL="25400" marR="101600" marT="63500" marB="63500" anchor="ctr">
@@ -9364,28 +9364,28 @@
                         <a:buNone/>
                       </a:pPr>
                       <a:r>
-                        <a:rPr lang="en-US" sz="1500" dirty="0">
+                        <a:rPr lang="en-US" sz="1600" dirty="0">
                           <a:solidFill>
                             <a:schemeClr val="tx1"/>
                           </a:solidFill>
                         </a:rPr>
                         <a:t>Low 0 (80); int 1 (42);</a:t>
                       </a:r>
-                      <a:endParaRPr lang="en-US" sz="1500" dirty="0"/>
-                    </a:p>
-                    <a:p>
-                      <a:pPr indent="0" marL="0">
-                        <a:buNone/>
-                      </a:pPr>
-                      <a:r>
-                        <a:rPr lang="en-US" sz="1500" dirty="0">
+                      <a:endParaRPr lang="en-US" sz="1600" dirty="0"/>
+                    </a:p>
+                    <a:p>
+                      <a:pPr indent="0" marL="0">
+                        <a:buNone/>
+                      </a:pPr>
+                      <a:r>
+                        <a:rPr lang="en-US" sz="1600" dirty="0">
                           <a:solidFill>
                             <a:schemeClr val="tx1"/>
                           </a:solidFill>
                         </a:rPr>
                         <a:t>high ≥ 2 (11)</a:t>
                       </a:r>
-                      <a:endParaRPr lang="en-US" sz="1500" dirty="0"/>
+                      <a:endParaRPr lang="en-US" sz="1600" dirty="0"/>
                     </a:p>
                   </a:txBody>
                   <a:tcPr marL="25400" marR="101600" marT="63500" marB="63500" anchor="ctr">
@@ -9420,14 +9420,14 @@
                         <a:buNone/>
                       </a:pPr>
                       <a:r>
-                        <a:rPr lang="en-US" sz="1500" dirty="0">
+                        <a:rPr lang="en-US" sz="1600" dirty="0">
                           <a:solidFill>
                             <a:schemeClr val="tx1"/>
                           </a:solidFill>
                         </a:rPr>
                         <a:t>MDS/MPN-NOS</a:t>
                       </a:r>
-                      <a:endParaRPr lang="en-US" sz="1500" dirty="0"/>
+                      <a:endParaRPr lang="en-US" sz="1600" dirty="0"/>
                     </a:p>
                   </a:txBody>
                   <a:tcPr marL="25400" marR="101600" marT="63500" marB="63500" anchor="ctr">
@@ -9460,14 +9460,14 @@
                         <a:buNone/>
                       </a:pPr>
                       <a:r>
-                        <a:rPr lang="en-US" sz="1500" dirty="0">
+                        <a:rPr lang="en-US" sz="1600" dirty="0">
                           <a:solidFill>
                             <a:schemeClr val="tx1"/>
                           </a:solidFill>
                         </a:rPr>
                         <a:t>No specific score or molecular marker</a:t>
                       </a:r>
-                      <a:endParaRPr lang="en-US" sz="1500" dirty="0"/>
+                      <a:endParaRPr lang="en-US" sz="1600" dirty="0"/>
                     </a:p>
                   </a:txBody>
                   <a:tcPr marL="25400" marR="101600" marT="63500" marB="63500" anchor="ctr">
@@ -9500,14 +9500,14 @@
                         <a:buNone/>
                       </a:pPr>
                       <a:r>
-                        <a:rPr lang="en-US" sz="1500" dirty="0">
+                        <a:rPr lang="en-US" sz="1600" dirty="0">
                           <a:solidFill>
                             <a:schemeClr val="tx1"/>
                           </a:solidFill>
                         </a:rPr>
                         <a:t>Median OS 12.4–33 (4 series)</a:t>
                       </a:r>
-                      <a:endParaRPr lang="en-US" sz="1500" dirty="0"/>
+                      <a:endParaRPr lang="en-US" sz="1600" dirty="0"/>
                     </a:p>
                   </a:txBody>
                   <a:tcPr marL="25400" marR="101600" marT="63500" marB="63500" anchor="ctr">
@@ -9566,7 +9566,7 @@
                   <a:schemeClr val="tx1"/>
                 </a:solidFill>
               </a:rPr>
-              <a:t>GFM anaemia: Hb &lt; 10 g/dL (F) or &lt; 11 g/dL (M); counts × 10⁹/L; Hb in g/dL</a:t>
+              <a:t>GFM anaemia: Hb &lt; 10 g/dL (F), &lt; 11 g/dL (M); I-1/I-2, intermediate-1/-2; counts × 10⁹/L</a:t>
             </a:r>
             <a:endParaRPr lang="en-US" sz="1600" dirty="0"/>
           </a:p>
@@ -10744,14 +10744,14 @@
                         <a:buNone/>
                       </a:pPr>
                       <a:r>
-                        <a:rPr lang="en-US" sz="1500" b="1" dirty="0">
+                        <a:rPr lang="en-US" sz="1600" b="1" dirty="0">
                           <a:solidFill>
                             <a:schemeClr val="tx1"/>
                           </a:solidFill>
                         </a:rPr>
                         <a:t>Situation</a:t>
                       </a:r>
-                      <a:endParaRPr lang="en-US" sz="1500" dirty="0"/>
+                      <a:endParaRPr lang="en-US" sz="1600" dirty="0"/>
                     </a:p>
                   </a:txBody>
                   <a:tcPr marL="25400" marR="101600" marT="63500" marB="63500" anchor="ctr">
@@ -10790,14 +10790,14 @@
                         <a:buNone/>
                       </a:pPr>
                       <a:r>
-                        <a:rPr lang="en-US" sz="1500" b="1" dirty="0">
+                        <a:rPr lang="en-US" sz="1600" b="1" dirty="0">
                           <a:solidFill>
                             <a:schemeClr val="tx1"/>
                           </a:solidFill>
                         </a:rPr>
                         <a:t>Bridge or control (Ch. 76)</a:t>
                       </a:r>
-                      <a:endParaRPr lang="en-US" sz="1500" dirty="0"/>
+                      <a:endParaRPr lang="en-US" sz="1600" dirty="0"/>
                     </a:p>
                   </a:txBody>
                   <a:tcPr marL="25400" marR="101600" marT="63500" marB="63500" anchor="ctr">
@@ -10838,14 +10838,14 @@
                         <a:buNone/>
                       </a:pPr>
                       <a:r>
-                        <a:rPr lang="en-US" sz="1500" dirty="0">
+                        <a:rPr lang="en-US" sz="1600" dirty="0">
                           <a:solidFill>
                             <a:schemeClr val="tx1"/>
                           </a:solidFill>
                         </a:rPr>
                         <a:t>High risk, marrow blasts &lt; 10%</a:t>
                       </a:r>
-                      <a:endParaRPr lang="en-US" sz="1500" dirty="0"/>
+                      <a:endParaRPr lang="en-US" sz="1600" dirty="0"/>
                     </a:p>
                   </a:txBody>
                   <a:tcPr marL="25400" marR="101600" marT="63500" marB="63500" anchor="ctr">
@@ -10878,14 +10878,14 @@
                         <a:buNone/>
                       </a:pPr>
                       <a:r>
-                        <a:rPr lang="en-US" sz="1500" dirty="0">
+                        <a:rPr lang="en-US" sz="1600" dirty="0">
                           <a:solidFill>
                             <a:schemeClr val="tx1"/>
                           </a:solidFill>
                         </a:rPr>
                         <a:t>Upfront allo-HCT preferred</a:t>
                       </a:r>
-                      <a:endParaRPr lang="en-US" sz="1500" dirty="0"/>
+                      <a:endParaRPr lang="en-US" sz="1600" dirty="0"/>
                     </a:p>
                   </a:txBody>
                   <a:tcPr marL="25400" marR="101600" marT="63500" marB="63500" anchor="ctr">
@@ -10920,14 +10920,14 @@
                         <a:buNone/>
                       </a:pPr>
                       <a:r>
-                        <a:rPr lang="en-US" sz="1500" dirty="0">
+                        <a:rPr lang="en-US" sz="1600" dirty="0">
                           <a:solidFill>
                             <a:schemeClr val="tx1"/>
                           </a:solidFill>
                         </a:rPr>
                         <a:t>CMML: rising WBC or organ infiltration</a:t>
                       </a:r>
-                      <a:endParaRPr lang="en-US" sz="1500" dirty="0"/>
+                      <a:endParaRPr lang="en-US" sz="1600" dirty="0"/>
                     </a:p>
                   </a:txBody>
                   <a:tcPr marL="25400" marR="101600" marT="63500" marB="63500" anchor="ctr">
@@ -10960,14 +10960,14 @@
                         <a:buNone/>
                       </a:pPr>
                       <a:r>
-                        <a:rPr lang="en-US" sz="1500" dirty="0">
+                        <a:rPr lang="en-US" sz="1600" dirty="0">
                           <a:solidFill>
                             <a:schemeClr val="tx1"/>
                           </a:solidFill>
                         </a:rPr>
                         <a:t>Hydroxyurea is the drug of choice</a:t>
                       </a:r>
-                      <a:endParaRPr lang="en-US" sz="1500" dirty="0"/>
+                      <a:endParaRPr lang="en-US" sz="1600" dirty="0"/>
                     </a:p>
                   </a:txBody>
                   <a:tcPr marL="25400" marR="101600" marT="63500" marB="63500" anchor="ctr">
@@ -11002,14 +11002,14 @@
                         <a:buNone/>
                       </a:pPr>
                       <a:r>
-                        <a:rPr lang="en-US" sz="1500" dirty="0">
+                        <a:rPr lang="en-US" sz="1600" dirty="0">
                           <a:solidFill>
                             <a:schemeClr val="tx1"/>
                           </a:solidFill>
                         </a:rPr>
                         <a:t>CMML-2 or marrow blasts &gt; 10%</a:t>
                       </a:r>
-                      <a:endParaRPr lang="en-US" sz="1500" dirty="0"/>
+                      <a:endParaRPr lang="en-US" sz="1600" dirty="0"/>
                     </a:p>
                   </a:txBody>
                   <a:tcPr marL="25400" marR="101600" marT="63500" marB="63500" anchor="ctr">
@@ -11042,14 +11042,14 @@
                         <a:buNone/>
                       </a:pPr>
                       <a:r>
-                        <a:rPr lang="en-US" sz="1500" dirty="0">
+                        <a:rPr lang="en-US" sz="1600" dirty="0">
                           <a:solidFill>
                             <a:schemeClr val="tx1"/>
                           </a:solidFill>
                         </a:rPr>
                         <a:t>HMA (ORR 40–50%) or AML-like induction</a:t>
                       </a:r>
-                      <a:endParaRPr lang="en-US" sz="1500" dirty="0"/>
+                      <a:endParaRPr lang="en-US" sz="1600" dirty="0"/>
                     </a:p>
                   </a:txBody>
                   <a:tcPr marL="25400" marR="101600" marT="63500" marB="63500" anchor="ctr">
@@ -11084,14 +11084,14 @@
                         <a:buNone/>
                       </a:pPr>
                       <a:r>
-                        <a:rPr lang="en-US" sz="1500" dirty="0">
+                        <a:rPr lang="en-US" sz="1600" dirty="0">
                           <a:solidFill>
                             <a:schemeClr val="tx1"/>
                           </a:solidFill>
                         </a:rPr>
                         <a:t>MDS/MPN-N: leukocytosis</a:t>
                       </a:r>
-                      <a:endParaRPr lang="en-US" sz="1500" dirty="0"/>
+                      <a:endParaRPr lang="en-US" sz="1600" dirty="0"/>
                     </a:p>
                   </a:txBody>
                   <a:tcPr marL="25400" marR="101600" marT="63500" marB="63500" anchor="ctr">
@@ -11124,14 +11124,14 @@
                         <a:buNone/>
                       </a:pPr>
                       <a:r>
-                        <a:rPr lang="en-US" sz="1500" dirty="0">
+                        <a:rPr lang="en-US" sz="1600" dirty="0">
                           <a:solidFill>
                             <a:schemeClr val="tx1"/>
                           </a:solidFill>
                         </a:rPr>
                         <a:t>HU or IFN-α; induction if high blasts or AML</a:t>
                       </a:r>
-                      <a:endParaRPr lang="en-US" sz="1500" dirty="0"/>
+                      <a:endParaRPr lang="en-US" sz="1600" dirty="0"/>
                     </a:p>
                   </a:txBody>
                   <a:tcPr marL="25400" marR="101600" marT="63500" marB="63500" anchor="ctr">
@@ -11166,14 +11166,14 @@
                         <a:buNone/>
                       </a:pPr>
                       <a:r>
-                        <a:rPr lang="en-US" sz="1500" dirty="0">
+                        <a:rPr lang="en-US" sz="1600" dirty="0">
                           <a:solidFill>
                             <a:schemeClr val="tx1"/>
                           </a:solidFill>
                         </a:rPr>
                         <a:t>MDS/MPN-N: mutations</a:t>
                       </a:r>
-                      <a:endParaRPr lang="en-US" sz="1500" dirty="0"/>
+                      <a:endParaRPr lang="en-US" sz="1600" dirty="0"/>
                     </a:p>
                   </a:txBody>
                   <a:tcPr marL="25400" marR="101600" marT="63500" marB="63500" anchor="ctr">
@@ -11206,14 +11206,14 @@
                         <a:buNone/>
                       </a:pPr>
                       <a:r>
-                        <a:rPr lang="en-US" sz="1500" dirty="0">
+                        <a:rPr lang="en-US" sz="1600" dirty="0">
                           <a:solidFill>
                             <a:schemeClr val="tx1"/>
                           </a:solidFill>
                         </a:rPr>
                         <a:t>ASXL1 43%, SETBP1 30%, ETNK1 16%; JAK2 0–7%</a:t>
                       </a:r>
-                      <a:endParaRPr lang="en-US" sz="1500" dirty="0"/>
+                      <a:endParaRPr lang="en-US" sz="1600" dirty="0"/>
                     </a:p>
                   </a:txBody>
                   <a:tcPr marL="25400" marR="101600" marT="63500" marB="63500" anchor="ctr">
@@ -11248,14 +11248,14 @@
                         <a:buNone/>
                       </a:pPr>
                       <a:r>
-                        <a:rPr lang="en-US" sz="1500" dirty="0">
+                        <a:rPr lang="en-US" sz="1600" dirty="0">
                           <a:solidFill>
                             <a:schemeClr val="tx1"/>
                           </a:solidFill>
                         </a:rPr>
                         <a:t>MDS/MPN-SF3B1-T</a:t>
                       </a:r>
-                      <a:endParaRPr lang="en-US" sz="1500" dirty="0"/>
+                      <a:endParaRPr lang="en-US" sz="1600" dirty="0"/>
                     </a:p>
                   </a:txBody>
                   <a:tcPr marL="25400" marR="101600" marT="63500" marB="63500" anchor="ctr">
@@ -11288,14 +11288,14 @@
                         <a:buNone/>
                       </a:pPr>
                       <a:r>
-                        <a:rPr lang="en-US" sz="1500" dirty="0">
+                        <a:rPr lang="en-US" sz="1600" dirty="0">
                           <a:solidFill>
                             <a:schemeClr val="tx1"/>
                           </a:solidFill>
                         </a:rPr>
                         <a:t>Lenalidomide for transfusions; antiplatelet, cytoreduction</a:t>
                       </a:r>
-                      <a:endParaRPr lang="en-US" sz="1500" dirty="0"/>
+                      <a:endParaRPr lang="en-US" sz="1600" dirty="0"/>
                     </a:p>
                   </a:txBody>
                   <a:tcPr marL="25400" marR="101600" marT="63500" marB="63500" anchor="ctr">
@@ -11330,14 +11330,14 @@
                         <a:buNone/>
                       </a:pPr>
                       <a:r>
-                        <a:rPr lang="en-US" sz="1500" dirty="0">
+                        <a:rPr lang="en-US" sz="1600" dirty="0">
                           <a:solidFill>
                             <a:schemeClr val="tx1"/>
                           </a:solidFill>
                         </a:rPr>
                         <a:t>MDS/MPN-NOS</a:t>
                       </a:r>
-                      <a:endParaRPr lang="en-US" sz="1500" dirty="0"/>
+                      <a:endParaRPr lang="en-US" sz="1600" dirty="0"/>
                     </a:p>
                   </a:txBody>
                   <a:tcPr marL="25400" marR="101600" marT="63500" marB="63500" anchor="ctr">
@@ -11370,28 +11370,28 @@
                         <a:buNone/>
                       </a:pPr>
                       <a:r>
-                        <a:rPr lang="en-US" sz="1500" dirty="0">
-                          <a:solidFill>
-                            <a:schemeClr val="tx1"/>
-                          </a:solidFill>
-                        </a:rPr>
-                        <a:t>HU or IFN-α if proliferative; HMA or lenalidomide</a:t>
-                      </a:r>
-                      <a:endParaRPr lang="en-US" sz="1500" dirty="0"/>
-                    </a:p>
-                    <a:p>
-                      <a:pPr indent="0" marL="0">
-                        <a:buNone/>
-                      </a:pPr>
-                      <a:r>
-                        <a:rPr lang="en-US" sz="1500" dirty="0">
-                          <a:solidFill>
-                            <a:schemeClr val="tx1"/>
-                          </a:solidFill>
-                        </a:rPr>
-                        <a:t>if cytopenic</a:t>
-                      </a:r>
-                      <a:endParaRPr lang="en-US" sz="1500" dirty="0"/>
+                        <a:rPr lang="en-US" sz="1600" dirty="0">
+                          <a:solidFill>
+                            <a:schemeClr val="tx1"/>
+                          </a:solidFill>
+                        </a:rPr>
+                        <a:t>HU/IFN-α if proliferative;</a:t>
+                      </a:r>
+                      <a:endParaRPr lang="en-US" sz="1600" dirty="0"/>
+                    </a:p>
+                    <a:p>
+                      <a:pPr indent="0" marL="0">
+                        <a:buNone/>
+                      </a:pPr>
+                      <a:r>
+                        <a:rPr lang="en-US" sz="1600" dirty="0">
+                          <a:solidFill>
+                            <a:schemeClr val="tx1"/>
+                          </a:solidFill>
+                        </a:rPr>
+                        <a:t>HMA or lenalidomide if cytopenic</a:t>
+                      </a:r>
+                      <a:endParaRPr lang="en-US" sz="1600" dirty="0"/>
                     </a:p>
                   </a:txBody>
                   <a:tcPr marL="25400" marR="101600" marT="63500" marB="63500" anchor="ctr">
@@ -11426,14 +11426,14 @@
                         <a:buNone/>
                       </a:pPr>
                       <a:r>
-                        <a:rPr lang="en-US" sz="1500" dirty="0">
+                        <a:rPr lang="en-US" sz="1600" dirty="0">
                           <a:solidFill>
                             <a:schemeClr val="tx1"/>
                           </a:solidFill>
                         </a:rPr>
                         <a:t>Progression to AML (any entity)</a:t>
                       </a:r>
-                      <a:endParaRPr lang="en-US" sz="1500" dirty="0"/>
+                      <a:endParaRPr lang="en-US" sz="1600" dirty="0"/>
                     </a:p>
                   </a:txBody>
                   <a:tcPr marL="25400" marR="101600" marT="63500" marB="63500" anchor="ctr">
@@ -11466,14 +11466,14 @@
                         <a:buNone/>
                       </a:pPr>
                       <a:r>
-                        <a:rPr lang="en-US" sz="1500" dirty="0">
+                        <a:rPr lang="en-US" sz="1600" dirty="0">
                           <a:solidFill>
                             <a:schemeClr val="tx1"/>
                           </a:solidFill>
                         </a:rPr>
                         <a:t>Induction chemotherapy as a bridge</a:t>
                       </a:r>
-                      <a:endParaRPr lang="en-US" sz="1500" dirty="0"/>
+                      <a:endParaRPr lang="en-US" sz="1600" dirty="0"/>
                     </a:p>
                   </a:txBody>
                   <a:tcPr marL="25400" marR="101600" marT="63500" marB="63500" anchor="ctr">
@@ -11722,14 +11722,14 @@
                         <a:buNone/>
                       </a:pPr>
                       <a:r>
-                        <a:rPr lang="en-US" sz="1600" b="1" dirty="0">
+                        <a:rPr lang="en-US" sz="1700" b="1" dirty="0">
                           <a:solidFill>
                             <a:schemeClr val="tx1"/>
                           </a:solidFill>
                         </a:rPr>
                         <a:t>Decision</a:t>
                       </a:r>
-                      <a:endParaRPr lang="en-US" sz="1600" dirty="0"/>
+                      <a:endParaRPr lang="en-US" sz="1700" dirty="0"/>
                     </a:p>
                   </a:txBody>
                   <a:tcPr marL="25400" marR="101600" marT="63500" marB="63500" anchor="ctr">
@@ -11768,14 +11768,14 @@
                         <a:buNone/>
                       </a:pPr>
                       <a:r>
-                        <a:rPr lang="en-US" sz="1600" b="1" dirty="0">
+                        <a:rPr lang="en-US" sz="1700" b="1" dirty="0">
                           <a:solidFill>
                             <a:schemeClr val="tx1"/>
                           </a:solidFill>
                         </a:rPr>
                         <a:t>Chapter guidance</a:t>
                       </a:r>
-                      <a:endParaRPr lang="en-US" sz="1600" dirty="0"/>
+                      <a:endParaRPr lang="en-US" sz="1700" dirty="0"/>
                     </a:p>
                   </a:txBody>
                   <a:tcPr marL="25400" marR="101600" marT="63500" marB="63500" anchor="ctr">
@@ -11816,14 +11816,14 @@
                         <a:buNone/>
                       </a:pPr>
                       <a:r>
-                        <a:rPr lang="en-US" sz="1600" dirty="0">
+                        <a:rPr lang="en-US" sz="1700" dirty="0">
                           <a:solidFill>
                             <a:schemeClr val="tx1"/>
                           </a:solidFill>
                         </a:rPr>
                         <a:t>Age &lt; 60 and HCT-CI &lt; 3</a:t>
                       </a:r>
-                      <a:endParaRPr lang="en-US" sz="1600" dirty="0"/>
+                      <a:endParaRPr lang="en-US" sz="1700" dirty="0"/>
                     </a:p>
                   </a:txBody>
                   <a:tcPr marL="25400" marR="101600" marT="63500" marB="63500" anchor="ctr">
@@ -11856,14 +11856,14 @@
                         <a:buNone/>
                       </a:pPr>
                       <a:r>
-                        <a:rPr lang="en-US" sz="1600" dirty="0">
+                        <a:rPr lang="en-US" sz="1700" dirty="0">
                           <a:solidFill>
                             <a:schemeClr val="tx1"/>
                           </a:solidFill>
                         </a:rPr>
                         <a:t>MAC: BU-CY, TBF, TTF or FB4; esp. proliferative</a:t>
                       </a:r>
-                      <a:endParaRPr lang="en-US" sz="1600" dirty="0"/>
+                      <a:endParaRPr lang="en-US" sz="1700" dirty="0"/>
                     </a:p>
                   </a:txBody>
                   <a:tcPr marL="25400" marR="101600" marT="63500" marB="63500" anchor="ctr">
@@ -11898,14 +11898,14 @@
                         <a:buNone/>
                       </a:pPr>
                       <a:r>
-                        <a:rPr lang="en-US" sz="1600" dirty="0">
+                        <a:rPr lang="en-US" sz="1700" dirty="0">
                           <a:solidFill>
                             <a:schemeClr val="tx1"/>
                           </a:solidFill>
                         </a:rPr>
                         <a:t>Older, comorbid or in remission</a:t>
                       </a:r>
-                      <a:endParaRPr lang="en-US" sz="1600" dirty="0"/>
+                      <a:endParaRPr lang="en-US" sz="1700" dirty="0"/>
                     </a:p>
                   </a:txBody>
                   <a:tcPr marL="25400" marR="101600" marT="63500" marB="63500" anchor="ctr">
@@ -11938,14 +11938,14 @@
                         <a:buNone/>
                       </a:pPr>
                       <a:r>
-                        <a:rPr lang="en-US" sz="1600" dirty="0">
+                        <a:rPr lang="en-US" sz="1700" dirty="0">
                           <a:solidFill>
                             <a:schemeClr val="tx1"/>
                           </a:solidFill>
                         </a:rPr>
                         <a:t>RIC: BU/FLU, TREO10/FLU, reduced TBF/TTF</a:t>
                       </a:r>
-                      <a:endParaRPr lang="en-US" sz="1600" dirty="0"/>
+                      <a:endParaRPr lang="en-US" sz="1700" dirty="0"/>
                     </a:p>
                   </a:txBody>
                   <a:tcPr marL="25400" marR="101600" marT="63500" marB="63500" anchor="ctr">
@@ -11980,14 +11980,14 @@
                         <a:buNone/>
                       </a:pPr>
                       <a:r>
-                        <a:rPr lang="en-US" sz="1600" dirty="0">
+                        <a:rPr lang="en-US" sz="1700" dirty="0">
                           <a:solidFill>
                             <a:schemeClr val="tx1"/>
                           </a:solidFill>
                         </a:rPr>
                         <a:t>Largest CMML series</a:t>
                       </a:r>
-                      <a:endParaRPr lang="en-US" sz="1600" dirty="0"/>
+                      <a:endParaRPr lang="en-US" sz="1700" dirty="0"/>
                     </a:p>
                   </a:txBody>
                   <a:tcPr marL="25400" marR="101600" marT="63500" marB="63500" anchor="ctr">
@@ -12020,14 +12020,14 @@
                         <a:buNone/>
                       </a:pPr>
                       <a:r>
-                        <a:rPr lang="en-US" sz="1600" dirty="0">
+                        <a:rPr lang="en-US" sz="1700" dirty="0">
                           <a:solidFill>
                             <a:schemeClr val="tx1"/>
                           </a:solidFill>
                         </a:rPr>
                         <a:t>MAC and RIC about equal; no outcome difference</a:t>
                       </a:r>
-                      <a:endParaRPr lang="en-US" sz="1600" dirty="0"/>
+                      <a:endParaRPr lang="en-US" sz="1700" dirty="0"/>
                     </a:p>
                   </a:txBody>
                   <a:tcPr marL="25400" marR="101600" marT="63500" marB="63500" anchor="ctr">
@@ -12062,14 +12062,14 @@
                         <a:buNone/>
                       </a:pPr>
                       <a:r>
-                        <a:rPr lang="en-US" sz="1600" dirty="0">
+                        <a:rPr lang="en-US" sz="1700" dirty="0">
                           <a:solidFill>
                             <a:schemeClr val="tx1"/>
                           </a:solidFill>
                         </a:rPr>
                         <a:t>Advanced CMML</a:t>
                       </a:r>
-                      <a:endParaRPr lang="en-US" sz="1600" dirty="0"/>
+                      <a:endParaRPr lang="en-US" sz="1700" dirty="0"/>
                     </a:p>
                   </a:txBody>
                   <a:tcPr marL="25400" marR="101600" marT="63500" marB="63500" anchor="ctr">
@@ -12102,28 +12102,28 @@
                         <a:buNone/>
                       </a:pPr>
                       <a:r>
-                        <a:rPr lang="en-US" sz="1600" dirty="0">
+                        <a:rPr lang="en-US" sz="1700" dirty="0">
                           <a:solidFill>
                             <a:schemeClr val="tx1"/>
                           </a:solidFill>
                         </a:rPr>
                         <a:t>Fractionated 6–8 Gy TBI/FLU: improved outcome</a:t>
                       </a:r>
-                      <a:endParaRPr lang="en-US" sz="1600" dirty="0"/>
-                    </a:p>
-                    <a:p>
-                      <a:pPr indent="0" marL="0">
-                        <a:buNone/>
-                      </a:pPr>
-                      <a:r>
-                        <a:rPr lang="en-US" sz="1600" dirty="0">
+                      <a:endParaRPr lang="en-US" sz="1700" dirty="0"/>
+                    </a:p>
+                    <a:p>
+                      <a:pPr indent="0" marL="0">
+                        <a:buNone/>
+                      </a:pPr>
+                      <a:r>
+                        <a:rPr lang="en-US" sz="1700" dirty="0">
                           <a:solidFill>
                             <a:schemeClr val="tx1"/>
                           </a:solidFill>
                         </a:rPr>
                         <a:t>(one report)</a:t>
                       </a:r>
-                      <a:endParaRPr lang="en-US" sz="1600" dirty="0"/>
+                      <a:endParaRPr lang="en-US" sz="1700" dirty="0"/>
                     </a:p>
                   </a:txBody>
                   <a:tcPr marL="25400" marR="101600" marT="63500" marB="63500" anchor="ctr">
@@ -12158,14 +12158,14 @@
                         <a:buNone/>
                       </a:pPr>
                       <a:r>
-                        <a:rPr lang="en-US" sz="1600" dirty="0">
+                        <a:rPr lang="en-US" sz="1700" dirty="0">
                           <a:solidFill>
                             <a:schemeClr val="tx1"/>
                           </a:solidFill>
                         </a:rPr>
                         <a:t>Stem cell source</a:t>
                       </a:r>
-                      <a:endParaRPr lang="en-US" sz="1600" dirty="0"/>
+                      <a:endParaRPr lang="en-US" sz="1700" dirty="0"/>
                     </a:p>
                   </a:txBody>
                   <a:tcPr marL="25400" marR="101600" marT="63500" marB="63500" anchor="ctr">
@@ -12198,28 +12198,28 @@
                         <a:buNone/>
                       </a:pPr>
                       <a:r>
-                        <a:rPr lang="en-US" sz="1600" dirty="0">
+                        <a:rPr lang="en-US" sz="1700" dirty="0">
                           <a:solidFill>
                             <a:schemeClr val="tx1"/>
                           </a:solidFill>
                         </a:rPr>
                         <a:t>Open; PBSC may cut graft failure and relapse,</a:t>
                       </a:r>
-                      <a:endParaRPr lang="en-US" sz="1600" dirty="0"/>
-                    </a:p>
-                    <a:p>
-                      <a:pPr indent="0" marL="0">
-                        <a:buNone/>
-                      </a:pPr>
-                      <a:r>
-                        <a:rPr lang="en-US" sz="1600" dirty="0">
+                      <a:endParaRPr lang="en-US" sz="1700" dirty="0"/>
+                    </a:p>
+                    <a:p>
+                      <a:pPr indent="0" marL="0">
+                        <a:buNone/>
+                      </a:pPr>
+                      <a:r>
+                        <a:rPr lang="en-US" sz="1700" dirty="0">
                           <a:solidFill>
                             <a:schemeClr val="tx1"/>
                           </a:solidFill>
                         </a:rPr>
                         <a:t>esp. with RIC</a:t>
                       </a:r>
-                      <a:endParaRPr lang="en-US" sz="1600" dirty="0"/>
+                      <a:endParaRPr lang="en-US" sz="1700" dirty="0"/>
                     </a:p>
                   </a:txBody>
                   <a:tcPr marL="25400" marR="101600" marT="63500" marB="63500" anchor="ctr">
@@ -12254,14 +12254,14 @@
                         <a:buNone/>
                       </a:pPr>
                       <a:r>
-                        <a:rPr lang="en-US" sz="1600" dirty="0">
+                        <a:rPr lang="en-US" sz="1700" dirty="0">
                           <a:solidFill>
                             <a:schemeClr val="tx1"/>
                           </a:solidFill>
                         </a:rPr>
                         <a:t>Autologous HCT</a:t>
                       </a:r>
-                      <a:endParaRPr lang="en-US" sz="1600" dirty="0"/>
+                      <a:endParaRPr lang="en-US" sz="1700" dirty="0"/>
                     </a:p>
                   </a:txBody>
                   <a:tcPr marL="25400" marR="101600" marT="63500" marB="63500" anchor="ctr">
@@ -12294,14 +12294,14 @@
                         <a:buNone/>
                       </a:pPr>
                       <a:r>
-                        <a:rPr lang="en-US" sz="1600" dirty="0">
+                        <a:rPr lang="en-US" sz="1700" dirty="0">
                           <a:solidFill>
                             <a:schemeClr val="tx1"/>
                           </a:solidFill>
                         </a:rPr>
                         <a:t>Not recommended: no polyclonal harvest</a:t>
                       </a:r>
-                      <a:endParaRPr lang="en-US" sz="1600" dirty="0"/>
+                      <a:endParaRPr lang="en-US" sz="1700" dirty="0"/>
                     </a:p>
                   </a:txBody>
                   <a:tcPr marL="25400" marR="101600" marT="63500" marB="63500" anchor="ctr">
@@ -12336,14 +12336,14 @@
                         <a:buNone/>
                       </a:pPr>
                       <a:r>
-                        <a:rPr lang="en-US" sz="1600" dirty="0">
+                        <a:rPr lang="en-US" sz="1700" dirty="0">
                           <a:solidFill>
                             <a:schemeClr val="tx1"/>
                           </a:solidFill>
                         </a:rPr>
                         <a:t>After HCT</a:t>
                       </a:r>
-                      <a:endParaRPr lang="en-US" sz="1600" dirty="0"/>
+                      <a:endParaRPr lang="en-US" sz="1700" dirty="0"/>
                     </a:p>
                   </a:txBody>
                   <a:tcPr marL="25400" marR="101600" marT="63500" marB="63500" anchor="ctr">
@@ -12376,28 +12376,28 @@
                         <a:buNone/>
                       </a:pPr>
                       <a:r>
-                        <a:rPr lang="en-US" sz="1600" dirty="0">
-                          <a:solidFill>
-                            <a:schemeClr val="tx1"/>
-                          </a:solidFill>
-                        </a:rPr>
-                        <a:t>cGVHD lowers relapse; DLI at low burden;</a:t>
-                      </a:r>
-                      <a:endParaRPr lang="en-US" sz="1600" dirty="0"/>
-                    </a:p>
-                    <a:p>
-                      <a:pPr indent="0" marL="0">
-                        <a:buNone/>
-                      </a:pPr>
-                      <a:r>
-                        <a:rPr lang="en-US" sz="1600" dirty="0">
+                        <a:rPr lang="en-US" sz="1700" dirty="0">
+                          <a:solidFill>
+                            <a:schemeClr val="tx1"/>
+                          </a:solidFill>
+                        </a:rPr>
+                        <a:t>cGVHD: less relapse; DLI at low burden;</a:t>
+                      </a:r>
+                      <a:endParaRPr lang="en-US" sz="1700" dirty="0"/>
+                    </a:p>
+                    <a:p>
+                      <a:pPr indent="0" marL="0">
+                        <a:buNone/>
+                      </a:pPr>
+                      <a:r>
+                        <a:rPr lang="en-US" sz="1700" dirty="0">
                           <a:solidFill>
                             <a:schemeClr val="tx1"/>
                           </a:solidFill>
                         </a:rPr>
                         <a:t>HMA ± DLI under study</a:t>
                       </a:r>
-                      <a:endParaRPr lang="en-US" sz="1600" dirty="0"/>
+                      <a:endParaRPr lang="en-US" sz="1700" dirty="0"/>
                     </a:p>
                   </a:txBody>
                   <a:tcPr marL="25400" marR="101600" marT="63500" marB="63500" anchor="ctr">
@@ -17003,14 +17003,14 @@
                         <a:buNone/>
                       </a:pPr>
                       <a:r>
-                        <a:rPr lang="en-US" sz="1500" b="1" dirty="0">
+                        <a:rPr lang="en-US" sz="1600" b="1" dirty="0">
                           <a:solidFill>
                             <a:schemeClr val="tx1"/>
                           </a:solidFill>
                         </a:rPr>
                         <a:t>Study</a:t>
                       </a:r>
-                      <a:endParaRPr lang="en-US" sz="1500" dirty="0"/>
+                      <a:endParaRPr lang="en-US" sz="1600" dirty="0"/>
                     </a:p>
                   </a:txBody>
                   <a:tcPr marL="25400" marR="101600" marT="63500" marB="63500" anchor="ctr">
@@ -17049,14 +17049,14 @@
                         <a:buNone/>
                       </a:pPr>
                       <a:r>
-                        <a:rPr lang="en-US" sz="1500" b="1" dirty="0">
+                        <a:rPr lang="en-US" sz="1600" b="1" dirty="0">
                           <a:solidFill>
                             <a:schemeClr val="tx1"/>
                           </a:solidFill>
                         </a:rPr>
                         <a:t>n; median age</a:t>
                       </a:r>
-                      <a:endParaRPr lang="en-US" sz="1500" dirty="0"/>
+                      <a:endParaRPr lang="en-US" sz="1600" dirty="0"/>
                     </a:p>
                   </a:txBody>
                   <a:tcPr marL="25400" marR="101600" marT="63500" marB="63500" anchor="ctr">
@@ -17095,14 +17095,14 @@
                         <a:buNone/>
                       </a:pPr>
                       <a:r>
-                        <a:rPr lang="en-US" sz="1500" b="1" dirty="0">
+                        <a:rPr lang="en-US" sz="1600" b="1" dirty="0">
                           <a:solidFill>
                             <a:schemeClr val="tx1"/>
                           </a:solidFill>
                         </a:rPr>
                         <a:t>MAC / RIC</a:t>
                       </a:r>
-                      <a:endParaRPr lang="en-US" sz="1500" dirty="0"/>
+                      <a:endParaRPr lang="en-US" sz="1600" dirty="0"/>
                     </a:p>
                   </a:txBody>
                   <a:tcPr marL="25400" marR="101600" marT="63500" marB="63500" anchor="ctr">
@@ -17141,14 +17141,14 @@
                         <a:buNone/>
                       </a:pPr>
                       <a:r>
-                        <a:rPr lang="en-US" sz="1500" b="1" dirty="0">
+                        <a:rPr lang="en-US" sz="1600" b="1" dirty="0">
                           <a:solidFill>
                             <a:schemeClr val="tx1"/>
                           </a:solidFill>
                         </a:rPr>
                         <a:t>TRM / relapse</a:t>
                       </a:r>
-                      <a:endParaRPr lang="en-US" sz="1500" dirty="0"/>
+                      <a:endParaRPr lang="en-US" sz="1600" dirty="0"/>
                     </a:p>
                   </a:txBody>
                   <a:tcPr marL="25400" marR="101600" marT="63500" marB="63500" anchor="ctr">
@@ -17187,14 +17187,14 @@
                         <a:buNone/>
                       </a:pPr>
                       <a:r>
-                        <a:rPr lang="en-US" sz="1500" b="1" dirty="0">
+                        <a:rPr lang="en-US" sz="1600" b="1" dirty="0">
                           <a:solidFill>
                             <a:schemeClr val="tx1"/>
                           </a:solidFill>
                         </a:rPr>
                         <a:t>Survival</a:t>
                       </a:r>
-                      <a:endParaRPr lang="en-US" sz="1500" dirty="0"/>
+                      <a:endParaRPr lang="en-US" sz="1600" dirty="0"/>
                     </a:p>
                   </a:txBody>
                   <a:tcPr marL="25400" marR="101600" marT="63500" marB="63500" anchor="ctr">
@@ -17235,14 +17235,14 @@
                         <a:buNone/>
                       </a:pPr>
                       <a:r>
-                        <a:rPr lang="en-US" sz="1500" dirty="0">
+                        <a:rPr lang="en-US" sz="1600" dirty="0">
                           <a:solidFill>
                             <a:schemeClr val="tx1"/>
                           </a:solidFill>
                         </a:rPr>
                         <a:t>Kröger 2002 (CMML)</a:t>
                       </a:r>
-                      <a:endParaRPr lang="en-US" sz="1500" dirty="0"/>
+                      <a:endParaRPr lang="en-US" sz="1600" dirty="0"/>
                     </a:p>
                   </a:txBody>
                   <a:tcPr marL="25400" marR="101600" marT="63500" marB="63500" anchor="ctr">
@@ -17275,14 +17275,14 @@
                         <a:buNone/>
                       </a:pPr>
                       <a:r>
-                        <a:rPr lang="en-US" sz="1500" dirty="0">
+                        <a:rPr lang="en-US" sz="1600" dirty="0">
                           <a:solidFill>
                             <a:schemeClr val="tx1"/>
                           </a:solidFill>
                         </a:rPr>
                         <a:t>50; 44</a:t>
                       </a:r>
-                      <a:endParaRPr lang="en-US" sz="1500" dirty="0"/>
+                      <a:endParaRPr lang="en-US" sz="1600" dirty="0"/>
                     </a:p>
                   </a:txBody>
                   <a:tcPr marL="25400" marR="101600" marT="63500" marB="63500" anchor="ctr">
@@ -17315,14 +17315,14 @@
                         <a:buNone/>
                       </a:pPr>
                       <a:r>
-                        <a:rPr lang="en-US" sz="1500" dirty="0">
+                        <a:rPr lang="en-US" sz="1600" dirty="0">
                           <a:solidFill>
                             <a:schemeClr val="tx1"/>
                           </a:solidFill>
                         </a:rPr>
                         <a:t>50 / 0</a:t>
                       </a:r>
-                      <a:endParaRPr lang="en-US" sz="1500" dirty="0"/>
+                      <a:endParaRPr lang="en-US" sz="1600" dirty="0"/>
                     </a:p>
                   </a:txBody>
                   <a:tcPr marL="25400" marR="101600" marT="63500" marB="63500" anchor="ctr">
@@ -17355,14 +17355,14 @@
                         <a:buNone/>
                       </a:pPr>
                       <a:r>
-                        <a:rPr lang="en-US" sz="1500" dirty="0">
+                        <a:rPr lang="en-US" sz="1600" dirty="0">
                           <a:solidFill>
                             <a:schemeClr val="tx1"/>
                           </a:solidFill>
                         </a:rPr>
                         <a:t>52% / 28%</a:t>
                       </a:r>
-                      <a:endParaRPr lang="en-US" sz="1500" dirty="0"/>
+                      <a:endParaRPr lang="en-US" sz="1600" dirty="0"/>
                     </a:p>
                   </a:txBody>
                   <a:tcPr marL="25400" marR="101600" marT="63500" marB="63500" anchor="ctr">
@@ -17395,14 +17395,14 @@
                         <a:buNone/>
                       </a:pPr>
                       <a:r>
-                        <a:rPr lang="en-US" sz="1500" dirty="0">
+                        <a:rPr lang="en-US" sz="1600" dirty="0">
                           <a:solidFill>
                             <a:schemeClr val="tx1"/>
                           </a:solidFill>
                         </a:rPr>
                         <a:t>5-y OS 21%</a:t>
                       </a:r>
-                      <a:endParaRPr lang="en-US" sz="1500" dirty="0"/>
+                      <a:endParaRPr lang="en-US" sz="1600" dirty="0"/>
                     </a:p>
                   </a:txBody>
                   <a:tcPr marL="25400" marR="101600" marT="63500" marB="63500" anchor="ctr">
@@ -17437,14 +17437,14 @@
                         <a:buNone/>
                       </a:pPr>
                       <a:r>
-                        <a:rPr lang="en-US" sz="1500" dirty="0">
+                        <a:rPr lang="en-US" sz="1600" dirty="0">
                           <a:solidFill>
                             <a:schemeClr val="tx1"/>
                           </a:solidFill>
                         </a:rPr>
                         <a:t>Symeonidis 2015 (CMML)</a:t>
                       </a:r>
-                      <a:endParaRPr lang="en-US" sz="1500" dirty="0"/>
+                      <a:endParaRPr lang="en-US" sz="1600" dirty="0"/>
                     </a:p>
                   </a:txBody>
                   <a:tcPr marL="25400" marR="101600" marT="63500" marB="63500" anchor="ctr">
@@ -17477,14 +17477,14 @@
                         <a:buNone/>
                       </a:pPr>
                       <a:r>
-                        <a:rPr lang="en-US" sz="1500" dirty="0">
+                        <a:rPr lang="en-US" sz="1600" dirty="0">
                           <a:solidFill>
                             <a:schemeClr val="tx1"/>
                           </a:solidFill>
                         </a:rPr>
                         <a:t>513; 53</a:t>
                       </a:r>
-                      <a:endParaRPr lang="en-US" sz="1500" dirty="0"/>
+                      <a:endParaRPr lang="en-US" sz="1600" dirty="0"/>
                     </a:p>
                   </a:txBody>
                   <a:tcPr marL="25400" marR="101600" marT="63500" marB="63500" anchor="ctr">
@@ -17517,14 +17517,14 @@
                         <a:buNone/>
                       </a:pPr>
                       <a:r>
-                        <a:rPr lang="en-US" sz="1500" dirty="0">
+                        <a:rPr lang="en-US" sz="1600" dirty="0">
                           <a:solidFill>
                             <a:schemeClr val="tx1"/>
                           </a:solidFill>
                         </a:rPr>
                         <a:t>249 / 226</a:t>
                       </a:r>
-                      <a:endParaRPr lang="en-US" sz="1500" dirty="0"/>
+                      <a:endParaRPr lang="en-US" sz="1600" dirty="0"/>
                     </a:p>
                   </a:txBody>
                   <a:tcPr marL="25400" marR="101600" marT="63500" marB="63500" anchor="ctr">
@@ -17557,14 +17557,14 @@
                         <a:buNone/>
                       </a:pPr>
                       <a:r>
-                        <a:rPr lang="en-US" sz="1500" dirty="0">
+                        <a:rPr lang="en-US" sz="1600" dirty="0">
                           <a:solidFill>
                             <a:schemeClr val="tx1"/>
                           </a:solidFill>
                         </a:rPr>
                         <a:t>4-y 41% / 32%</a:t>
                       </a:r>
-                      <a:endParaRPr lang="en-US" sz="1500" dirty="0"/>
+                      <a:endParaRPr lang="en-US" sz="1600" dirty="0"/>
                     </a:p>
                   </a:txBody>
                   <a:tcPr marL="25400" marR="101600" marT="63500" marB="63500" anchor="ctr">
@@ -17597,14 +17597,14 @@
                         <a:buNone/>
                       </a:pPr>
                       <a:r>
-                        <a:rPr lang="en-US" sz="1500" dirty="0">
+                        <a:rPr lang="en-US" sz="1600" dirty="0">
                           <a:solidFill>
                             <a:schemeClr val="tx1"/>
                           </a:solidFill>
                         </a:rPr>
                         <a:t>4-y OS 33%</a:t>
                       </a:r>
-                      <a:endParaRPr lang="en-US" sz="1500" dirty="0"/>
+                      <a:endParaRPr lang="en-US" sz="1600" dirty="0"/>
                     </a:p>
                   </a:txBody>
                   <a:tcPr marL="25400" marR="101600" marT="63500" marB="63500" anchor="ctr">
@@ -17639,14 +17639,14 @@
                         <a:buNone/>
                       </a:pPr>
                       <a:r>
-                        <a:rPr lang="en-US" sz="1500" dirty="0">
+                        <a:rPr lang="en-US" sz="1600" dirty="0">
                           <a:solidFill>
                             <a:schemeClr val="tx1"/>
                           </a:solidFill>
                         </a:rPr>
                         <a:t>Liu 2017 (CMML)</a:t>
                       </a:r>
-                      <a:endParaRPr lang="en-US" sz="1500" dirty="0"/>
+                      <a:endParaRPr lang="en-US" sz="1600" dirty="0"/>
                     </a:p>
                   </a:txBody>
                   <a:tcPr marL="25400" marR="101600" marT="63500" marB="63500" anchor="ctr">
@@ -17679,14 +17679,14 @@
                         <a:buNone/>
                       </a:pPr>
                       <a:r>
-                        <a:rPr lang="en-US" sz="1500" dirty="0">
+                        <a:rPr lang="en-US" sz="1600" dirty="0">
                           <a:solidFill>
                             <a:schemeClr val="tx1"/>
                           </a:solidFill>
                         </a:rPr>
                         <a:t>209; 57</a:t>
                       </a:r>
-                      <a:endParaRPr lang="en-US" sz="1500" dirty="0"/>
+                      <a:endParaRPr lang="en-US" sz="1600" dirty="0"/>
                     </a:p>
                   </a:txBody>
                   <a:tcPr marL="25400" marR="101600" marT="63500" marB="63500" anchor="ctr">
@@ -17719,14 +17719,14 @@
                         <a:buNone/>
                       </a:pPr>
                       <a:r>
-                        <a:rPr lang="en-US" sz="1500" dirty="0">
+                        <a:rPr lang="en-US" sz="1600" dirty="0">
                           <a:solidFill>
                             <a:schemeClr val="tx1"/>
                           </a:solidFill>
                         </a:rPr>
                         <a:t>105 / 99</a:t>
                       </a:r>
-                      <a:endParaRPr lang="en-US" sz="1500" dirty="0"/>
+                      <a:endParaRPr lang="en-US" sz="1600" dirty="0"/>
                     </a:p>
                   </a:txBody>
                   <a:tcPr marL="25400" marR="101600" marT="63500" marB="63500" anchor="ctr">
@@ -17759,14 +17759,14 @@
                         <a:buNone/>
                       </a:pPr>
                       <a:r>
-                        <a:rPr lang="en-US" sz="1500" dirty="0">
+                        <a:rPr lang="en-US" sz="1600" dirty="0">
                           <a:solidFill>
                             <a:schemeClr val="tx1"/>
                           </a:solidFill>
                         </a:rPr>
                         <a:t>5-y 28% / 52%</a:t>
                       </a:r>
-                      <a:endParaRPr lang="en-US" sz="1500" dirty="0"/>
+                      <a:endParaRPr lang="en-US" sz="1600" dirty="0"/>
                     </a:p>
                   </a:txBody>
                   <a:tcPr marL="25400" marR="101600" marT="63500" marB="63500" anchor="ctr">
@@ -17799,14 +17799,14 @@
                         <a:buNone/>
                       </a:pPr>
                       <a:r>
-                        <a:rPr lang="en-US" sz="1500" dirty="0">
+                        <a:rPr lang="en-US" sz="1600" dirty="0">
                           <a:solidFill>
                             <a:schemeClr val="tx1"/>
                           </a:solidFill>
                         </a:rPr>
                         <a:t>5-y OS 30%</a:t>
                       </a:r>
-                      <a:endParaRPr lang="en-US" sz="1500" dirty="0"/>
+                      <a:endParaRPr lang="en-US" sz="1600" dirty="0"/>
                     </a:p>
                   </a:txBody>
                   <a:tcPr marL="25400" marR="101600" marT="63500" marB="63500" anchor="ctr">
@@ -17841,14 +17841,14 @@
                         <a:buNone/>
                       </a:pPr>
                       <a:r>
-                        <a:rPr lang="en-US" sz="1500" dirty="0">
+                        <a:rPr lang="en-US" sz="1600" dirty="0">
                           <a:solidFill>
                             <a:schemeClr val="tx1"/>
                           </a:solidFill>
                         </a:rPr>
                         <a:t>Itonaga 2018 (CMML)</a:t>
                       </a:r>
-                      <a:endParaRPr lang="en-US" sz="1500" dirty="0"/>
+                      <a:endParaRPr lang="en-US" sz="1600" dirty="0"/>
                     </a:p>
                   </a:txBody>
                   <a:tcPr marL="25400" marR="101600" marT="63500" marB="63500" anchor="ctr">
@@ -17881,14 +17881,14 @@
                         <a:buNone/>
                       </a:pPr>
                       <a:r>
-                        <a:rPr lang="en-US" sz="1500" dirty="0">
+                        <a:rPr lang="en-US" sz="1600" dirty="0">
                           <a:solidFill>
                             <a:schemeClr val="tx1"/>
                           </a:solidFill>
                         </a:rPr>
                         <a:t>159; 54</a:t>
                       </a:r>
-                      <a:endParaRPr lang="en-US" sz="1500" dirty="0"/>
+                      <a:endParaRPr lang="en-US" sz="1600" dirty="0"/>
                     </a:p>
                   </a:txBody>
                   <a:tcPr marL="25400" marR="101600" marT="63500" marB="63500" anchor="ctr">
@@ -17921,14 +17921,14 @@
                         <a:buNone/>
                       </a:pPr>
                       <a:r>
-                        <a:rPr lang="en-US" sz="1500" dirty="0">
+                        <a:rPr lang="en-US" sz="1600" dirty="0">
                           <a:solidFill>
                             <a:schemeClr val="tx1"/>
                           </a:solidFill>
                         </a:rPr>
                         <a:t>92 / 67</a:t>
                       </a:r>
-                      <a:endParaRPr lang="en-US" sz="1500" dirty="0"/>
+                      <a:endParaRPr lang="en-US" sz="1600" dirty="0"/>
                     </a:p>
                   </a:txBody>
                   <a:tcPr marL="25400" marR="101600" marT="63500" marB="63500" anchor="ctr">
@@ -17961,14 +17961,14 @@
                         <a:buNone/>
                       </a:pPr>
                       <a:r>
-                        <a:rPr lang="en-US" sz="1500" dirty="0">
+                        <a:rPr lang="en-US" sz="1600" dirty="0">
                           <a:solidFill>
                             <a:schemeClr val="tx1"/>
                           </a:solidFill>
                         </a:rPr>
                         <a:t>28% / 39%</a:t>
                       </a:r>
-                      <a:endParaRPr lang="en-US" sz="1500" dirty="0"/>
+                      <a:endParaRPr lang="en-US" sz="1600" dirty="0"/>
                     </a:p>
                   </a:txBody>
                   <a:tcPr marL="25400" marR="101600" marT="63500" marB="63500" anchor="ctr">
@@ -18001,14 +18001,14 @@
                         <a:buNone/>
                       </a:pPr>
                       <a:r>
-                        <a:rPr lang="en-US" sz="1500" dirty="0">
+                        <a:rPr lang="en-US" sz="1600" dirty="0">
                           <a:solidFill>
                             <a:schemeClr val="tx1"/>
                           </a:solidFill>
                         </a:rPr>
                         <a:t>3-y OS 33%</a:t>
                       </a:r>
-                      <a:endParaRPr lang="en-US" sz="1500" dirty="0"/>
+                      <a:endParaRPr lang="en-US" sz="1600" dirty="0"/>
                     </a:p>
                   </a:txBody>
                   <a:tcPr marL="25400" marR="101600" marT="63500" marB="63500" anchor="ctr">
@@ -18043,14 +18043,14 @@
                         <a:buNone/>
                       </a:pPr>
                       <a:r>
-                        <a:rPr lang="en-US" sz="1500" dirty="0">
+                        <a:rPr lang="en-US" sz="1600" dirty="0">
                           <a:solidFill>
                             <a:schemeClr val="tx1"/>
                           </a:solidFill>
                         </a:rPr>
                         <a:t>Rovó 2023 (CMML)</a:t>
                       </a:r>
-                      <a:endParaRPr lang="en-US" sz="1500" dirty="0"/>
+                      <a:endParaRPr lang="en-US" sz="1600" dirty="0"/>
                     </a:p>
                   </a:txBody>
                   <a:tcPr marL="25400" marR="101600" marT="63500" marB="63500" anchor="ctr">
@@ -18083,14 +18083,14 @@
                         <a:buNone/>
                       </a:pPr>
                       <a:r>
-                        <a:rPr lang="en-US" sz="1500" dirty="0">
+                        <a:rPr lang="en-US" sz="1600" dirty="0">
                           <a:solidFill>
                             <a:schemeClr val="tx1"/>
                           </a:solidFill>
                         </a:rPr>
                         <a:t>1466; 60</a:t>
                       </a:r>
-                      <a:endParaRPr lang="en-US" sz="1500" dirty="0"/>
+                      <a:endParaRPr lang="en-US" sz="1600" dirty="0"/>
                     </a:p>
                   </a:txBody>
                   <a:tcPr marL="25400" marR="101600" marT="63500" marB="63500" anchor="ctr">
@@ -18123,14 +18123,14 @@
                         <a:buNone/>
                       </a:pPr>
                       <a:r>
-                        <a:rPr lang="en-US" sz="1500" dirty="0">
+                        <a:rPr lang="en-US" sz="1600" dirty="0">
                           <a:solidFill>
                             <a:schemeClr val="tx1"/>
                           </a:solidFill>
                         </a:rPr>
                         <a:t>36% / 64%</a:t>
                       </a:r>
-                      <a:endParaRPr lang="en-US" sz="1500" dirty="0"/>
+                      <a:endParaRPr lang="en-US" sz="1600" dirty="0"/>
                     </a:p>
                   </a:txBody>
                   <a:tcPr marL="25400" marR="101600" marT="63500" marB="63500" anchor="ctr">
@@ -18163,14 +18163,14 @@
                         <a:buNone/>
                       </a:pPr>
                       <a:r>
-                        <a:rPr lang="en-US" sz="1500" dirty="0">
+                        <a:rPr lang="en-US" sz="1600" dirty="0">
                           <a:solidFill>
                             <a:schemeClr val="tx1"/>
                           </a:solidFill>
                         </a:rPr>
                         <a:t>32% / 37%</a:t>
                       </a:r>
-                      <a:endParaRPr lang="en-US" sz="1500" dirty="0"/>
+                      <a:endParaRPr lang="en-US" sz="1600" dirty="0"/>
                     </a:p>
                   </a:txBody>
                   <a:tcPr marL="25400" marR="101600" marT="63500" marB="63500" anchor="ctr">
@@ -18203,14 +18203,14 @@
                         <a:buNone/>
                       </a:pPr>
                       <a:r>
-                        <a:rPr lang="en-US" sz="1500" dirty="0">
+                        <a:rPr lang="en-US" sz="1600" dirty="0">
                           <a:solidFill>
                             <a:schemeClr val="tx1"/>
                           </a:solidFill>
                         </a:rPr>
                         <a:t>5-y OS 37%</a:t>
                       </a:r>
-                      <a:endParaRPr lang="en-US" sz="1500" dirty="0"/>
+                      <a:endParaRPr lang="en-US" sz="1600" dirty="0"/>
                     </a:p>
                   </a:txBody>
                   <a:tcPr marL="25400" marR="101600" marT="63500" marB="63500" anchor="ctr">
@@ -18245,14 +18245,14 @@
                         <a:buNone/>
                       </a:pPr>
                       <a:r>
-                        <a:rPr lang="en-US" sz="1500" dirty="0">
+                        <a:rPr lang="en-US" sz="1600" dirty="0">
                           <a:solidFill>
                             <a:schemeClr val="tx1"/>
                           </a:solidFill>
                         </a:rPr>
                         <a:t>Onida 2017 (MDS/MPN-N)</a:t>
                       </a:r>
-                      <a:endParaRPr lang="en-US" sz="1500" dirty="0"/>
+                      <a:endParaRPr lang="en-US" sz="1600" dirty="0"/>
                     </a:p>
                   </a:txBody>
                   <a:tcPr marL="25400" marR="101600" marT="63500" marB="63500" anchor="ctr">
@@ -18285,14 +18285,14 @@
                         <a:buNone/>
                       </a:pPr>
                       <a:r>
-                        <a:rPr lang="en-US" sz="1500" dirty="0">
+                        <a:rPr lang="en-US" sz="1600" dirty="0">
                           <a:solidFill>
                             <a:schemeClr val="tx1"/>
                           </a:solidFill>
                         </a:rPr>
                         <a:t>42</a:t>
                       </a:r>
-                      <a:endParaRPr lang="en-US" sz="1500" dirty="0"/>
+                      <a:endParaRPr lang="en-US" sz="1600" dirty="0"/>
                     </a:p>
                   </a:txBody>
                   <a:tcPr marL="25400" marR="101600" marT="63500" marB="63500" anchor="ctr">
@@ -18325,14 +18325,14 @@
                         <a:buNone/>
                       </a:pPr>
                       <a:r>
-                        <a:rPr lang="en-US" sz="1500" dirty="0">
+                        <a:rPr lang="en-US" sz="1600" dirty="0">
                           <a:solidFill>
                             <a:schemeClr val="tx1"/>
                           </a:solidFill>
                         </a:rPr>
                         <a:t>MAC 76%</a:t>
                       </a:r>
-                      <a:endParaRPr lang="en-US" sz="1500" dirty="0"/>
+                      <a:endParaRPr lang="en-US" sz="1600" dirty="0"/>
                     </a:p>
                   </a:txBody>
                   <a:tcPr marL="25400" marR="101600" marT="63500" marB="63500" anchor="ctr">
@@ -18365,14 +18365,14 @@
                         <a:buNone/>
                       </a:pPr>
                       <a:r>
-                        <a:rPr lang="en-US" sz="1500" dirty="0">
+                        <a:rPr lang="en-US" sz="1600" dirty="0">
                           <a:solidFill>
                             <a:schemeClr val="tx1"/>
                           </a:solidFill>
                         </a:rPr>
                         <a:t>Relapse 40%</a:t>
                       </a:r>
-                      <a:endParaRPr lang="en-US" sz="1500" dirty="0"/>
+                      <a:endParaRPr lang="en-US" sz="1600" dirty="0"/>
                     </a:p>
                   </a:txBody>
                   <a:tcPr marL="25400" marR="101600" marT="63500" marB="63500" anchor="ctr">
@@ -18405,14 +18405,14 @@
                         <a:buNone/>
                       </a:pPr>
                       <a:r>
-                        <a:rPr lang="en-US" sz="1500" dirty="0">
+                        <a:rPr lang="en-US" sz="1600" dirty="0">
                           <a:solidFill>
                             <a:schemeClr val="tx1"/>
                           </a:solidFill>
                         </a:rPr>
                         <a:t>5-y OS 51%, RFS 36%</a:t>
                       </a:r>
-                      <a:endParaRPr lang="en-US" sz="1500" dirty="0"/>
+                      <a:endParaRPr lang="en-US" sz="1600" dirty="0"/>
                     </a:p>
                   </a:txBody>
                   <a:tcPr marL="25400" marR="101600" marT="63500" marB="63500" anchor="ctr">
@@ -18661,14 +18661,14 @@
                         <a:buNone/>
                       </a:pPr>
                       <a:r>
-                        <a:rPr lang="en-US" sz="1500" b="1" dirty="0">
+                        <a:rPr lang="en-US" sz="1600" b="1" dirty="0">
                           <a:solidFill>
                             <a:schemeClr val="tx1"/>
                           </a:solidFill>
                         </a:rPr>
                         <a:t>Setting</a:t>
                       </a:r>
-                      <a:endParaRPr lang="en-US" sz="1500" dirty="0"/>
+                      <a:endParaRPr lang="en-US" sz="1600" dirty="0"/>
                     </a:p>
                   </a:txBody>
                   <a:tcPr marL="25400" marR="101600" marT="63500" marB="63500" anchor="ctr">
@@ -18707,14 +18707,14 @@
                         <a:buNone/>
                       </a:pPr>
                       <a:r>
-                        <a:rPr lang="en-US" sz="1500" b="1" dirty="0">
+                        <a:rPr lang="en-US" sz="1600" b="1" dirty="0">
                           <a:solidFill>
                             <a:schemeClr val="tx1"/>
                           </a:solidFill>
                         </a:rPr>
                         <a:t>Chapter guidance</a:t>
                       </a:r>
-                      <a:endParaRPr lang="en-US" sz="1500" dirty="0"/>
+                      <a:endParaRPr lang="en-US" sz="1600" dirty="0"/>
                     </a:p>
                   </a:txBody>
                   <a:tcPr marL="25400" marR="101600" marT="63500" marB="63500" anchor="ctr">
@@ -18755,14 +18755,14 @@
                         <a:buNone/>
                       </a:pPr>
                       <a:r>
-                        <a:rPr lang="en-US" sz="1500" dirty="0">
+                        <a:rPr lang="en-US" sz="1600" dirty="0">
                           <a:solidFill>
                             <a:schemeClr val="tx1"/>
                           </a:solidFill>
                         </a:rPr>
                         <a:t>RCC with −7, del(7q) or ≥ 2 aberrations</a:t>
                       </a:r>
-                      <a:endParaRPr lang="en-US" sz="1500" dirty="0"/>
+                      <a:endParaRPr lang="en-US" sz="1600" dirty="0"/>
                     </a:p>
                   </a:txBody>
                   <a:tcPr marL="25400" marR="101600" marT="63500" marB="63500" anchor="ctr">
@@ -18795,14 +18795,14 @@
                         <a:buNone/>
                       </a:pPr>
                       <a:r>
-                        <a:rPr lang="en-US" sz="1500" dirty="0">
+                        <a:rPr lang="en-US" sz="1600" dirty="0">
                           <a:solidFill>
                             <a:schemeClr val="tx1"/>
                           </a:solidFill>
                         </a:rPr>
                         <a:t>Transplant early; MAC (TREO-based); OS ~90%</a:t>
                       </a:r>
-                      <a:endParaRPr lang="en-US" sz="1500" dirty="0"/>
+                      <a:endParaRPr lang="en-US" sz="1600" dirty="0"/>
                     </a:p>
                   </a:txBody>
                   <a:tcPr marL="25400" marR="101600" marT="63500" marB="63500" anchor="ctr">
@@ -18837,14 +18837,14 @@
                         <a:buNone/>
                       </a:pPr>
                       <a:r>
-                        <a:rPr lang="en-US" sz="1500" dirty="0">
+                        <a:rPr lang="en-US" sz="1600" dirty="0">
                           <a:solidFill>
                             <a:schemeClr val="tx1"/>
                           </a:solidFill>
                         </a:rPr>
                         <a:t>Hypocellular RCC, normal karyotype</a:t>
                       </a:r>
-                      <a:endParaRPr lang="en-US" sz="1500" dirty="0"/>
+                      <a:endParaRPr lang="en-US" sz="1600" dirty="0"/>
                     </a:p>
                   </a:txBody>
                   <a:tcPr marL="25400" marR="101600" marT="63500" marB="63500" anchor="ctr">
@@ -18877,28 +18877,28 @@
                         <a:buNone/>
                       </a:pPr>
                       <a:r>
-                        <a:rPr lang="en-US" sz="1500" dirty="0">
+                        <a:rPr lang="en-US" sz="1600" dirty="0">
                           <a:solidFill>
                             <a:schemeClr val="tx1"/>
                           </a:solidFill>
                         </a:rPr>
                         <a:t>RIC: TT/FLU OS 94% (Strahm 2017); now TREO/FLU;</a:t>
                       </a:r>
-                      <a:endParaRPr lang="en-US" sz="1500" dirty="0"/>
-                    </a:p>
-                    <a:p>
-                      <a:pPr indent="0" marL="0">
-                        <a:buNone/>
-                      </a:pPr>
-                      <a:r>
-                        <a:rPr lang="en-US" sz="1500" dirty="0">
+                      <a:endParaRPr lang="en-US" sz="1600" dirty="0"/>
+                    </a:p>
+                    <a:p>
+                      <a:pPr indent="0" marL="0">
+                        <a:buNone/>
+                      </a:pPr>
+                      <a:r>
+                        <a:rPr lang="en-US" sz="1600" dirty="0">
                           <a:solidFill>
                             <a:schemeClr val="tx1"/>
                           </a:solidFill>
                         </a:rPr>
                         <a:t>BM graft</a:t>
                       </a:r>
-                      <a:endParaRPr lang="en-US" sz="1500" dirty="0"/>
+                      <a:endParaRPr lang="en-US" sz="1600" dirty="0"/>
                     </a:p>
                   </a:txBody>
                   <a:tcPr marL="25400" marR="101600" marT="63500" marB="63500" anchor="ctr">
@@ -18933,14 +18933,14 @@
                         <a:buNone/>
                       </a:pPr>
                       <a:r>
-                        <a:rPr lang="en-US" sz="1500" dirty="0">
+                        <a:rPr lang="en-US" sz="1600" dirty="0">
                           <a:solidFill>
                             <a:schemeClr val="tx1"/>
                           </a:solidFill>
                         </a:rPr>
                         <a:t>Mild RCC, no −7, ANC &gt; 1 × 10⁹/L</a:t>
                       </a:r>
-                      <a:endParaRPr lang="en-US" sz="1500" dirty="0"/>
+                      <a:endParaRPr lang="en-US" sz="1600" dirty="0"/>
                     </a:p>
                   </a:txBody>
                   <a:tcPr marL="25400" marR="101600" marT="63500" marB="63500" anchor="ctr">
@@ -18973,14 +18973,14 @@
                         <a:buNone/>
                       </a:pPr>
                       <a:r>
-                        <a:rPr lang="en-US" sz="1500" dirty="0">
+                        <a:rPr lang="en-US" sz="1600" dirty="0">
                           <a:solidFill>
                             <a:schemeClr val="tx1"/>
                           </a:solidFill>
                         </a:rPr>
                         <a:t>Watch and observe</a:t>
                       </a:r>
-                      <a:endParaRPr lang="en-US" sz="1500" dirty="0"/>
+                      <a:endParaRPr lang="en-US" sz="1600" dirty="0"/>
                     </a:p>
                   </a:txBody>
                   <a:tcPr marL="25400" marR="101600" marT="63500" marB="63500" anchor="ctr">
@@ -19015,14 +19015,14 @@
                         <a:buNone/>
                       </a:pPr>
                       <a:r>
-                        <a:rPr lang="en-US" sz="1500" dirty="0">
+                        <a:rPr lang="en-US" sz="1600" dirty="0">
                           <a:solidFill>
                             <a:schemeClr val="tx1"/>
                           </a:solidFill>
                         </a:rPr>
                         <a:t>Primary MDS-EB</a:t>
                       </a:r>
-                      <a:endParaRPr lang="en-US" sz="1500" dirty="0"/>
+                      <a:endParaRPr lang="en-US" sz="1600" dirty="0"/>
                     </a:p>
                   </a:txBody>
                   <a:tcPr marL="25400" marR="101600" marT="63500" marB="63500" anchor="ctr">
@@ -19055,14 +19055,14 @@
                         <a:buNone/>
                       </a:pPr>
                       <a:r>
-                        <a:rPr lang="en-US" sz="1500" dirty="0">
+                        <a:rPr lang="en-US" sz="1600" dirty="0">
                           <a:solidFill>
                             <a:schemeClr val="tx1"/>
                           </a:solidFill>
                         </a:rPr>
                         <a:t>MAC BU/CY/MEL: 5-y OS 63% (Strahm 2011)</a:t>
                       </a:r>
-                      <a:endParaRPr lang="en-US" sz="1500" dirty="0"/>
+                      <a:endParaRPr lang="en-US" sz="1600" dirty="0"/>
                     </a:p>
                   </a:txBody>
                   <a:tcPr marL="25400" marR="101600" marT="63500" marB="63500" anchor="ctr">
@@ -19097,14 +19097,14 @@
                         <a:buNone/>
                       </a:pPr>
                       <a:r>
-                        <a:rPr lang="en-US" sz="1500" dirty="0">
+                        <a:rPr lang="en-US" sz="1600" dirty="0">
                           <a:solidFill>
                             <a:schemeClr val="tx1"/>
                           </a:solidFill>
                         </a:rPr>
                         <a:t>UBTF-TD (~1/3 of de novo MDS-EB)</a:t>
                       </a:r>
-                      <a:endParaRPr lang="en-US" sz="1500" dirty="0"/>
+                      <a:endParaRPr lang="en-US" sz="1600" dirty="0"/>
                     </a:p>
                   </a:txBody>
                   <a:tcPr marL="25400" marR="101600" marT="63500" marB="63500" anchor="ctr">
@@ -19137,14 +19137,14 @@
                         <a:buNone/>
                       </a:pPr>
                       <a:r>
-                        <a:rPr lang="en-US" sz="1500" dirty="0">
+                        <a:rPr lang="en-US" sz="1600" dirty="0">
                           <a:solidFill>
                             <a:schemeClr val="tx1"/>
                           </a:solidFill>
                         </a:rPr>
                         <a:t>Poor response to AML-type chemo; worse after HCT</a:t>
                       </a:r>
-                      <a:endParaRPr lang="en-US" sz="1500" dirty="0"/>
+                      <a:endParaRPr lang="en-US" sz="1600" dirty="0"/>
                     </a:p>
                   </a:txBody>
                   <a:tcPr marL="25400" marR="101600" marT="63500" marB="63500" anchor="ctr">
@@ -19179,14 +19179,14 @@
                         <a:buNone/>
                       </a:pPr>
                       <a:r>
-                        <a:rPr lang="en-US" sz="1500" dirty="0">
+                        <a:rPr lang="en-US" sz="1600" dirty="0">
                           <a:solidFill>
                             <a:schemeClr val="tx1"/>
                           </a:solidFill>
                         </a:rPr>
                         <a:t>GATA2 or SAMD9/SAMD9L germline</a:t>
                       </a:r>
-                      <a:endParaRPr lang="en-US" sz="1500" dirty="0"/>
+                      <a:endParaRPr lang="en-US" sz="1600" dirty="0"/>
                     </a:p>
                   </a:txBody>
                   <a:tcPr marL="25400" marR="101600" marT="63500" marB="63500" anchor="ctr">
@@ -19219,14 +19219,14 @@
                         <a:buNone/>
                       </a:pPr>
                       <a:r>
-                        <a:rPr lang="en-US" sz="1500" dirty="0">
+                        <a:rPr lang="en-US" sz="1600" dirty="0">
                           <a:solidFill>
                             <a:schemeClr val="tx1"/>
                           </a:solidFill>
                         </a:rPr>
                         <a:t>Same outcome when stratified; screen family donors</a:t>
                       </a:r>
-                      <a:endParaRPr lang="en-US" sz="1500" dirty="0"/>
+                      <a:endParaRPr lang="en-US" sz="1600" dirty="0"/>
                     </a:p>
                   </a:txBody>
                   <a:tcPr marL="25400" marR="101600" marT="63500" marB="63500" anchor="ctr">
@@ -19261,14 +19261,14 @@
                         <a:buNone/>
                       </a:pPr>
                       <a:r>
-                        <a:rPr lang="en-US" sz="1500" dirty="0">
+                        <a:rPr lang="en-US" sz="1600" dirty="0">
                           <a:solidFill>
                             <a:schemeClr val="tx1"/>
                           </a:solidFill>
                         </a:rPr>
                         <a:t>Therapy-related MDS</a:t>
                       </a:r>
-                      <a:endParaRPr lang="en-US" sz="1500" dirty="0"/>
+                      <a:endParaRPr lang="en-US" sz="1600" dirty="0"/>
                     </a:p>
                   </a:txBody>
                   <a:tcPr marL="25400" marR="101600" marT="63500" marB="63500" anchor="ctr">
@@ -19301,28 +19301,28 @@
                         <a:buNone/>
                       </a:pPr>
                       <a:r>
-                        <a:rPr lang="en-US" sz="1500" dirty="0">
+                        <a:rPr lang="en-US" sz="1600" dirty="0">
                           <a:solidFill>
                             <a:schemeClr val="tx1"/>
                           </a:solidFill>
                         </a:rPr>
                         <a:t>OS ≤ 20% with complex karyotype or TP53;</a:t>
                       </a:r>
-                      <a:endParaRPr lang="en-US" sz="1500" dirty="0"/>
-                    </a:p>
-                    <a:p>
-                      <a:pPr indent="0" marL="0">
-                        <a:buNone/>
-                      </a:pPr>
-                      <a:r>
-                        <a:rPr lang="en-US" sz="1500" dirty="0">
+                      <a:endParaRPr lang="en-US" sz="1600" dirty="0"/>
+                    </a:p>
+                    <a:p>
+                      <a:pPr indent="0" marL="0">
+                        <a:buNone/>
+                      </a:pPr>
+                      <a:r>
+                        <a:rPr lang="en-US" sz="1600" dirty="0">
                           <a:solidFill>
                             <a:schemeClr val="tx1"/>
                           </a:solidFill>
                         </a:rPr>
                         <a:t>~50% otherwise</a:t>
                       </a:r>
-                      <a:endParaRPr lang="en-US" sz="1500" dirty="0"/>
+                      <a:endParaRPr lang="en-US" sz="1600" dirty="0"/>
                     </a:p>
                   </a:txBody>
                   <a:tcPr marL="25400" marR="101600" marT="63500" marB="63500" anchor="ctr">
@@ -19571,14 +19571,14 @@
                         <a:buNone/>
                       </a:pPr>
                       <a:r>
-                        <a:rPr lang="en-US" sz="1500" b="1" dirty="0">
+                        <a:rPr lang="en-US" sz="1600" b="1" dirty="0">
                           <a:solidFill>
                             <a:schemeClr val="tx1"/>
                           </a:solidFill>
                         </a:rPr>
                         <a:t>Variable</a:t>
                       </a:r>
-                      <a:endParaRPr lang="en-US" sz="1500" dirty="0"/>
+                      <a:endParaRPr lang="en-US" sz="1600" dirty="0"/>
                     </a:p>
                   </a:txBody>
                   <a:tcPr marL="25400" marR="101600" marT="63500" marB="63500" anchor="ctr">
@@ -19617,14 +19617,14 @@
                         <a:buNone/>
                       </a:pPr>
                       <a:r>
-                        <a:rPr lang="en-US" sz="1500" b="1" dirty="0">
+                        <a:rPr lang="en-US" sz="1600" b="1" dirty="0">
                           <a:solidFill>
                             <a:schemeClr val="tx1"/>
                           </a:solidFill>
                         </a:rPr>
                         <a:t>Categories and points</a:t>
                       </a:r>
-                      <a:endParaRPr lang="en-US" sz="1500" dirty="0"/>
+                      <a:endParaRPr lang="en-US" sz="1600" dirty="0"/>
                     </a:p>
                   </a:txBody>
                   <a:tcPr marL="25400" marR="101600" marT="63500" marB="63500" anchor="ctr">
@@ -19665,14 +19665,14 @@
                         <a:buNone/>
                       </a:pPr>
                       <a:r>
-                        <a:rPr lang="en-US" sz="1500" dirty="0">
+                        <a:rPr lang="en-US" sz="1600" dirty="0">
                           <a:solidFill>
                             <a:schemeClr val="tx1"/>
                           </a:solidFill>
                         </a:rPr>
                         <a:t>Marrow blasts</a:t>
                       </a:r>
-                      <a:endParaRPr lang="en-US" sz="1500" dirty="0"/>
+                      <a:endParaRPr lang="en-US" sz="1600" dirty="0"/>
                     </a:p>
                   </a:txBody>
                   <a:tcPr marL="25400" marR="101600" marT="63500" marB="63500" anchor="ctr">
@@ -19705,14 +19705,14 @@
                         <a:buNone/>
                       </a:pPr>
                       <a:r>
-                        <a:rPr lang="en-US" sz="1500" dirty="0">
+                        <a:rPr lang="en-US" sz="1600" dirty="0">
                           <a:solidFill>
                             <a:schemeClr val="tx1"/>
                           </a:solidFill>
                         </a:rPr>
                         <a:t>&lt; 3% [0]; 3–4% [1]; 5–10% [2]; &gt; 10% [3]</a:t>
                       </a:r>
-                      <a:endParaRPr lang="en-US" sz="1500" dirty="0"/>
+                      <a:endParaRPr lang="en-US" sz="1600" dirty="0"/>
                     </a:p>
                   </a:txBody>
                   <a:tcPr marL="25400" marR="101600" marT="63500" marB="63500" anchor="ctr">
@@ -19747,14 +19747,14 @@
                         <a:buNone/>
                       </a:pPr>
                       <a:r>
-                        <a:rPr lang="en-US" sz="1500" dirty="0">
+                        <a:rPr lang="en-US" sz="1600" dirty="0">
                           <a:solidFill>
                             <a:schemeClr val="tx1"/>
                           </a:solidFill>
                         </a:rPr>
                         <a:t>Karyotype</a:t>
                       </a:r>
-                      <a:endParaRPr lang="en-US" sz="1500" dirty="0"/>
+                      <a:endParaRPr lang="en-US" sz="1600" dirty="0"/>
                     </a:p>
                   </a:txBody>
                   <a:tcPr marL="25400" marR="101600" marT="63500" marB="63500" anchor="ctr">
@@ -19787,14 +19787,14 @@
                         <a:buNone/>
                       </a:pPr>
                       <a:r>
-                        <a:rPr lang="en-US" sz="1500" dirty="0">
-                          <a:solidFill>
-                            <a:schemeClr val="tx1"/>
-                          </a:solidFill>
-                        </a:rPr>
-                        <a:t>Very good [0]; good [1]; intermediate [2]; poor [3]; very poor [4]</a:t>
-                      </a:r>
-                      <a:endParaRPr lang="en-US" sz="1500" dirty="0"/>
+                        <a:rPr lang="en-US" sz="1600" dirty="0">
+                          <a:solidFill>
+                            <a:schemeClr val="tx1"/>
+                          </a:solidFill>
+                        </a:rPr>
+                        <a:t>Very good [0]; good [1]; int [2]; poor [3]; very poor [4]</a:t>
+                      </a:r>
+                      <a:endParaRPr lang="en-US" sz="1600" dirty="0"/>
                     </a:p>
                   </a:txBody>
                   <a:tcPr marL="25400" marR="101600" marT="63500" marB="63500" anchor="ctr">
@@ -19829,14 +19829,14 @@
                         <a:buNone/>
                       </a:pPr>
                       <a:r>
-                        <a:rPr lang="en-US" sz="1500" dirty="0">
+                        <a:rPr lang="en-US" sz="1600" dirty="0">
                           <a:solidFill>
                             <a:schemeClr val="tx1"/>
                           </a:solidFill>
                         </a:rPr>
                         <a:t>Cytopenia</a:t>
                       </a:r>
-                      <a:endParaRPr lang="en-US" sz="1500" dirty="0"/>
+                      <a:endParaRPr lang="en-US" sz="1600" dirty="0"/>
                     </a:p>
                   </a:txBody>
                   <a:tcPr marL="25400" marR="101600" marT="63500" marB="63500" anchor="ctr">
@@ -19869,14 +19869,14 @@
                         <a:buNone/>
                       </a:pPr>
                       <a:r>
-                        <a:rPr lang="en-US" sz="1500" dirty="0">
+                        <a:rPr lang="en-US" sz="1600" dirty="0">
                           <a:solidFill>
                             <a:schemeClr val="tx1"/>
                           </a:solidFill>
                         </a:rPr>
                         <a:t>None [0]; mild [0.5]; moderate [1]; severe anaemia [1.5]</a:t>
                       </a:r>
-                      <a:endParaRPr lang="en-US" sz="1500" dirty="0"/>
+                      <a:endParaRPr lang="en-US" sz="1600" dirty="0"/>
                     </a:p>
                   </a:txBody>
                   <a:tcPr marL="25400" marR="101600" marT="63500" marB="63500" anchor="ctr">
@@ -19911,14 +19911,14 @@
                         <a:buNone/>
                       </a:pPr>
                       <a:r>
-                        <a:rPr lang="en-US" sz="1500" dirty="0">
+                        <a:rPr lang="en-US" sz="1600" dirty="0">
                           <a:solidFill>
                             <a:schemeClr val="tx1"/>
                           </a:solidFill>
                         </a:rPr>
                         <a:t>  Very good karyotype</a:t>
                       </a:r>
-                      <a:endParaRPr lang="en-US" sz="1500" dirty="0"/>
+                      <a:endParaRPr lang="en-US" sz="1600" dirty="0"/>
                     </a:p>
                   </a:txBody>
                   <a:tcPr marL="25400" marR="101600" marT="63500" marB="63500" anchor="ctr">
@@ -19951,14 +19951,14 @@
                         <a:buNone/>
                       </a:pPr>
                       <a:r>
-                        <a:rPr lang="en-US" sz="1500" dirty="0">
+                        <a:rPr lang="en-US" sz="1600" dirty="0">
                           <a:solidFill>
                             <a:schemeClr val="tx1"/>
                           </a:solidFill>
                         </a:rPr>
                         <a:t>−Y, del(11q)</a:t>
                       </a:r>
-                      <a:endParaRPr lang="en-US" sz="1500" dirty="0"/>
+                      <a:endParaRPr lang="en-US" sz="1600" dirty="0"/>
                     </a:p>
                   </a:txBody>
                   <a:tcPr marL="25400" marR="101600" marT="63500" marB="63500" anchor="ctr">
@@ -19993,14 +19993,14 @@
                         <a:buNone/>
                       </a:pPr>
                       <a:r>
-                        <a:rPr lang="en-US" sz="1500" dirty="0">
+                        <a:rPr lang="en-US" sz="1600" dirty="0">
                           <a:solidFill>
                             <a:schemeClr val="tx1"/>
                           </a:solidFill>
                         </a:rPr>
                         <a:t>  Good karyotype</a:t>
                       </a:r>
-                      <a:endParaRPr lang="en-US" sz="1500" dirty="0"/>
+                      <a:endParaRPr lang="en-US" sz="1600" dirty="0"/>
                     </a:p>
                   </a:txBody>
                   <a:tcPr marL="25400" marR="101600" marT="63500" marB="63500" anchor="ctr">
@@ -20033,14 +20033,14 @@
                         <a:buNone/>
                       </a:pPr>
                       <a:r>
-                        <a:rPr lang="en-US" sz="1500" dirty="0">
+                        <a:rPr lang="en-US" sz="1600" dirty="0">
                           <a:solidFill>
                             <a:schemeClr val="tx1"/>
                           </a:solidFill>
                         </a:rPr>
                         <a:t>Normal, del(5q), del(12p), del(20q), double incl. del(5q)</a:t>
                       </a:r>
-                      <a:endParaRPr lang="en-US" sz="1500" dirty="0"/>
+                      <a:endParaRPr lang="en-US" sz="1600" dirty="0"/>
                     </a:p>
                   </a:txBody>
                   <a:tcPr marL="25400" marR="101600" marT="63500" marB="63500" anchor="ctr">
@@ -20075,14 +20075,14 @@
                         <a:buNone/>
                       </a:pPr>
                       <a:r>
-                        <a:rPr lang="en-US" sz="1500" dirty="0">
+                        <a:rPr lang="en-US" sz="1600" dirty="0">
                           <a:solidFill>
                             <a:schemeClr val="tx1"/>
                           </a:solidFill>
                         </a:rPr>
                         <a:t>  Intermediate karyotype</a:t>
                       </a:r>
-                      <a:endParaRPr lang="en-US" sz="1500" dirty="0"/>
+                      <a:endParaRPr lang="en-US" sz="1600" dirty="0"/>
                     </a:p>
                   </a:txBody>
                   <a:tcPr marL="25400" marR="101600" marT="63500" marB="63500" anchor="ctr">
@@ -20115,14 +20115,14 @@
                         <a:buNone/>
                       </a:pPr>
                       <a:r>
-                        <a:rPr lang="en-US" sz="1500" dirty="0">
+                        <a:rPr lang="en-US" sz="1600" dirty="0">
                           <a:solidFill>
                             <a:schemeClr val="tx1"/>
                           </a:solidFill>
                         </a:rPr>
                         <a:t>del(7q), −8, −19, i(17q), any other single or double clone</a:t>
                       </a:r>
-                      <a:endParaRPr lang="en-US" sz="1500" dirty="0"/>
+                      <a:endParaRPr lang="en-US" sz="1600" dirty="0"/>
                     </a:p>
                   </a:txBody>
                   <a:tcPr marL="25400" marR="101600" marT="63500" marB="63500" anchor="ctr">
@@ -20157,14 +20157,14 @@
                         <a:buNone/>
                       </a:pPr>
                       <a:r>
-                        <a:rPr lang="en-US" sz="1500" dirty="0">
+                        <a:rPr lang="en-US" sz="1600" dirty="0">
                           <a:solidFill>
                             <a:schemeClr val="tx1"/>
                           </a:solidFill>
                         </a:rPr>
                         <a:t>  Poor karyotype</a:t>
                       </a:r>
-                      <a:endParaRPr lang="en-US" sz="1500" dirty="0"/>
+                      <a:endParaRPr lang="en-US" sz="1600" dirty="0"/>
                     </a:p>
                   </a:txBody>
                   <a:tcPr marL="25400" marR="101600" marT="63500" marB="63500" anchor="ctr">
@@ -20197,14 +20197,14 @@
                         <a:buNone/>
                       </a:pPr>
                       <a:r>
-                        <a:rPr lang="en-US" sz="1500" dirty="0">
+                        <a:rPr lang="en-US" sz="1600" dirty="0">
                           <a:solidFill>
                             <a:schemeClr val="tx1"/>
                           </a:solidFill>
                         </a:rPr>
                         <a:t>−7, inv(3)/t(3q)/del(3q), double incl. −7/del(7q), 3 abn.</a:t>
                       </a:r>
-                      <a:endParaRPr lang="en-US" sz="1500" dirty="0"/>
+                      <a:endParaRPr lang="en-US" sz="1600" dirty="0"/>
                     </a:p>
                   </a:txBody>
                   <a:tcPr marL="25400" marR="101600" marT="63500" marB="63500" anchor="ctr">
@@ -20239,14 +20239,14 @@
                         <a:buNone/>
                       </a:pPr>
                       <a:r>
-                        <a:rPr lang="en-US" sz="1500" dirty="0">
+                        <a:rPr lang="en-US" sz="1600" dirty="0">
                           <a:solidFill>
                             <a:schemeClr val="tx1"/>
                           </a:solidFill>
                         </a:rPr>
                         <a:t>  Very poor karyotype</a:t>
                       </a:r>
-                      <a:endParaRPr lang="en-US" sz="1500" dirty="0"/>
+                      <a:endParaRPr lang="en-US" sz="1600" dirty="0"/>
                     </a:p>
                   </a:txBody>
                   <a:tcPr marL="25400" marR="101600" marT="63500" marB="63500" anchor="ctr">
@@ -20279,14 +20279,14 @@
                         <a:buNone/>
                       </a:pPr>
                       <a:r>
-                        <a:rPr lang="en-US" sz="1500" dirty="0">
+                        <a:rPr lang="en-US" sz="1600" dirty="0">
                           <a:solidFill>
                             <a:schemeClr val="tx1"/>
                           </a:solidFill>
                         </a:rPr>
                         <a:t>Complex, &gt; 3 abnormalities</a:t>
                       </a:r>
-                      <a:endParaRPr lang="en-US" sz="1500" dirty="0"/>
+                      <a:endParaRPr lang="en-US" sz="1600" dirty="0"/>
                     </a:p>
                   </a:txBody>
                   <a:tcPr marL="25400" marR="101600" marT="63500" marB="63500" anchor="ctr">
@@ -20573,14 +20573,14 @@
                         <a:buNone/>
                       </a:pPr>
                       <a:r>
-                        <a:rPr lang="en-US" sz="1500" b="1" dirty="0">
+                        <a:rPr lang="en-US" sz="1600" b="1" dirty="0">
                           <a:solidFill>
                             <a:schemeClr val="tx1"/>
                           </a:solidFill>
                         </a:rPr>
                         <a:t>Subtype (share)</a:t>
                       </a:r>
-                      <a:endParaRPr lang="en-US" sz="1500" dirty="0"/>
+                      <a:endParaRPr lang="en-US" sz="1600" dirty="0"/>
                     </a:p>
                   </a:txBody>
                   <a:tcPr marL="25400" marR="101600" marT="63500" marB="63500" anchor="ctr">
@@ -20619,14 +20619,14 @@
                         <a:buNone/>
                       </a:pPr>
                       <a:r>
-                        <a:rPr lang="en-US" sz="1500" b="1" dirty="0">
+                        <a:rPr lang="en-US" sz="1600" b="1" dirty="0">
                           <a:solidFill>
                             <a:schemeClr val="tx1"/>
                           </a:solidFill>
                         </a:rPr>
                         <a:t>Features</a:t>
                       </a:r>
-                      <a:endParaRPr lang="en-US" sz="1500" dirty="0"/>
+                      <a:endParaRPr lang="en-US" sz="1600" dirty="0"/>
                     </a:p>
                   </a:txBody>
                   <a:tcPr marL="25400" marR="101600" marT="63500" marB="63500" anchor="ctr">
@@ -20665,14 +20665,14 @@
                         <a:buNone/>
                       </a:pPr>
                       <a:r>
-                        <a:rPr lang="en-US" sz="1500" b="1" dirty="0">
+                        <a:rPr lang="en-US" sz="1600" b="1" dirty="0">
                           <a:solidFill>
                             <a:schemeClr val="tx1"/>
                           </a:solidFill>
                         </a:rPr>
                         <a:t>Risk</a:t>
                       </a:r>
-                      <a:endParaRPr lang="en-US" sz="1500" dirty="0"/>
+                      <a:endParaRPr lang="en-US" sz="1600" dirty="0"/>
                     </a:p>
                   </a:txBody>
                   <a:tcPr marL="25400" marR="101600" marT="63500" marB="63500" anchor="ctr">
@@ -20711,14 +20711,14 @@
                         <a:buNone/>
                       </a:pPr>
                       <a:r>
-                        <a:rPr lang="en-US" sz="1500" b="1" dirty="0">
+                        <a:rPr lang="en-US" sz="1600" b="1" dirty="0">
                           <a:solidFill>
                             <a:schemeClr val="tx1"/>
                           </a:solidFill>
                         </a:rPr>
                         <a:t>HCT</a:t>
                       </a:r>
-                      <a:endParaRPr lang="en-US" sz="1500" dirty="0"/>
+                      <a:endParaRPr lang="en-US" sz="1600" dirty="0"/>
                     </a:p>
                   </a:txBody>
                   <a:tcPr marL="25400" marR="101600" marT="63500" marB="63500" anchor="ctr">
@@ -20759,14 +20759,14 @@
                         <a:buNone/>
                       </a:pPr>
                       <a:r>
-                        <a:rPr lang="en-US" sz="1500" dirty="0">
+                        <a:rPr lang="en-US" sz="1600" dirty="0">
                           <a:solidFill>
                             <a:schemeClr val="tx1"/>
                           </a:solidFill>
                         </a:rPr>
                         <a:t>PTPN11 (41%)</a:t>
                       </a:r>
-                      <a:endParaRPr lang="en-US" sz="1500" dirty="0"/>
+                      <a:endParaRPr lang="en-US" sz="1600" dirty="0"/>
                     </a:p>
                   </a:txBody>
                   <a:tcPr marL="25400" marR="101600" marT="63500" marB="63500" anchor="ctr">
@@ -20799,14 +20799,14 @@
                         <a:buNone/>
                       </a:pPr>
                       <a:r>
-                        <a:rPr lang="en-US" sz="1500" dirty="0">
+                        <a:rPr lang="en-US" sz="1600" dirty="0">
                           <a:solidFill>
                             <a:schemeClr val="tx1"/>
                           </a:solidFill>
                         </a:rPr>
                         <a:t>Somatic; exclude Noonan syndrome</a:t>
                       </a:r>
-                      <a:endParaRPr lang="en-US" sz="1500" dirty="0"/>
+                      <a:endParaRPr lang="en-US" sz="1600" dirty="0"/>
                     </a:p>
                   </a:txBody>
                   <a:tcPr marL="25400" marR="101600" marT="63500" marB="63500" anchor="ctr">
@@ -20839,14 +20839,14 @@
                         <a:buNone/>
                       </a:pPr>
                       <a:r>
-                        <a:rPr lang="en-US" sz="1500" dirty="0">
+                        <a:rPr lang="en-US" sz="1600" dirty="0">
                           <a:solidFill>
                             <a:schemeClr val="tx1"/>
                           </a:solidFill>
                         </a:rPr>
                         <a:t>Most often high</a:t>
                       </a:r>
-                      <a:endParaRPr lang="en-US" sz="1500" dirty="0"/>
+                      <a:endParaRPr lang="en-US" sz="1600" dirty="0"/>
                     </a:p>
                   </a:txBody>
                   <a:tcPr marL="25400" marR="101600" marT="63500" marB="63500" anchor="ctr">
@@ -20879,14 +20879,14 @@
                         <a:buNone/>
                       </a:pPr>
                       <a:r>
-                        <a:rPr lang="en-US" sz="1500" dirty="0">
+                        <a:rPr lang="en-US" sz="1600" dirty="0">
                           <a:solidFill>
                             <a:schemeClr val="tx1"/>
                           </a:solidFill>
                         </a:rPr>
                         <a:t>Indicated</a:t>
                       </a:r>
-                      <a:endParaRPr lang="en-US" sz="1500" dirty="0"/>
+                      <a:endParaRPr lang="en-US" sz="1600" dirty="0"/>
                     </a:p>
                   </a:txBody>
                   <a:tcPr marL="25400" marR="101600" marT="63500" marB="63500" anchor="ctr">
@@ -20921,14 +20921,14 @@
                         <a:buNone/>
                       </a:pPr>
                       <a:r>
-                        <a:rPr lang="en-US" sz="1500" dirty="0">
+                        <a:rPr lang="en-US" sz="1600" dirty="0">
                           <a:solidFill>
                             <a:schemeClr val="tx1"/>
                           </a:solidFill>
                         </a:rPr>
                         <a:t>NF1 (12%)</a:t>
                       </a:r>
-                      <a:endParaRPr lang="en-US" sz="1500" dirty="0"/>
+                      <a:endParaRPr lang="en-US" sz="1600" dirty="0"/>
                     </a:p>
                   </a:txBody>
                   <a:tcPr marL="25400" marR="101600" marT="63500" marB="63500" anchor="ctr">
@@ -20961,14 +20961,14 @@
                         <a:buNone/>
                       </a:pPr>
                       <a:r>
-                        <a:rPr lang="en-US" sz="1500" dirty="0">
+                        <a:rPr lang="en-US" sz="1600" dirty="0">
                           <a:solidFill>
                             <a:schemeClr val="tx1"/>
                           </a:solidFill>
                         </a:rPr>
                         <a:t>Germline NF1; older, higher platelets</a:t>
                       </a:r>
-                      <a:endParaRPr lang="en-US" sz="1500" dirty="0"/>
+                      <a:endParaRPr lang="en-US" sz="1600" dirty="0"/>
                     </a:p>
                   </a:txBody>
                   <a:tcPr marL="25400" marR="101600" marT="63500" marB="63500" anchor="ctr">
@@ -21001,14 +21001,14 @@
                         <a:buNone/>
                       </a:pPr>
                       <a:r>
-                        <a:rPr lang="en-US" sz="1500" dirty="0">
+                        <a:rPr lang="en-US" sz="1600" dirty="0">
                           <a:solidFill>
                             <a:schemeClr val="tx1"/>
                           </a:solidFill>
                         </a:rPr>
                         <a:t>Often high</a:t>
                       </a:r>
-                      <a:endParaRPr lang="en-US" sz="1500" dirty="0"/>
+                      <a:endParaRPr lang="en-US" sz="1600" dirty="0"/>
                     </a:p>
                   </a:txBody>
                   <a:tcPr marL="25400" marR="101600" marT="63500" marB="63500" anchor="ctr">
@@ -21041,14 +21041,14 @@
                         <a:buNone/>
                       </a:pPr>
                       <a:r>
-                        <a:rPr lang="en-US" sz="1500" dirty="0">
+                        <a:rPr lang="en-US" sz="1600" dirty="0">
                           <a:solidFill>
                             <a:schemeClr val="tx1"/>
                           </a:solidFill>
                         </a:rPr>
                         <a:t>Indicated</a:t>
                       </a:r>
-                      <a:endParaRPr lang="en-US" sz="1500" dirty="0"/>
+                      <a:endParaRPr lang="en-US" sz="1600" dirty="0"/>
                     </a:p>
                   </a:txBody>
                   <a:tcPr marL="25400" marR="101600" marT="63500" marB="63500" anchor="ctr">
@@ -21083,14 +21083,14 @@
                         <a:buNone/>
                       </a:pPr>
                       <a:r>
-                        <a:rPr lang="en-US" sz="1500" dirty="0">
+                        <a:rPr lang="en-US" sz="1600" dirty="0">
                           <a:solidFill>
                             <a:schemeClr val="tx1"/>
                           </a:solidFill>
                         </a:rPr>
                         <a:t>NRAS (16%)</a:t>
                       </a:r>
-                      <a:endParaRPr lang="en-US" sz="1500" dirty="0"/>
+                      <a:endParaRPr lang="en-US" sz="1600" dirty="0"/>
                     </a:p>
                   </a:txBody>
                   <a:tcPr marL="25400" marR="101600" marT="63500" marB="63500" anchor="ctr">
@@ -21123,14 +21123,14 @@
                         <a:buNone/>
                       </a:pPr>
                       <a:r>
-                        <a:rPr lang="en-US" sz="1500" dirty="0">
+                        <a:rPr lang="en-US" sz="1600" dirty="0">
                           <a:solidFill>
                             <a:schemeClr val="tx1"/>
                           </a:solidFill>
                         </a:rPr>
                         <a:t>Somatic; some regress spontaneously</a:t>
                       </a:r>
-                      <a:endParaRPr lang="en-US" sz="1500" dirty="0"/>
+                      <a:endParaRPr lang="en-US" sz="1600" dirty="0"/>
                     </a:p>
                   </a:txBody>
                   <a:tcPr marL="25400" marR="101600" marT="63500" marB="63500" anchor="ctr">
@@ -21163,14 +21163,14 @@
                         <a:buNone/>
                       </a:pPr>
                       <a:r>
-                        <a:rPr lang="en-US" sz="1500" dirty="0">
+                        <a:rPr lang="en-US" sz="1600" dirty="0">
                           <a:solidFill>
                             <a:schemeClr val="tx1"/>
                           </a:solidFill>
                         </a:rPr>
                         <a:t>Heterogeneous</a:t>
                       </a:r>
-                      <a:endParaRPr lang="en-US" sz="1500" dirty="0"/>
+                      <a:endParaRPr lang="en-US" sz="1600" dirty="0"/>
                     </a:p>
                   </a:txBody>
                   <a:tcPr marL="25400" marR="101600" marT="63500" marB="63500" anchor="ctr">
@@ -21203,14 +21203,14 @@
                         <a:buNone/>
                       </a:pPr>
                       <a:r>
-                        <a:rPr lang="en-US" sz="1500" dirty="0">
+                        <a:rPr lang="en-US" sz="1600" dirty="0">
                           <a:solidFill>
                             <a:schemeClr val="tx1"/>
                           </a:solidFill>
                         </a:rPr>
                         <a:t>High-risk only</a:t>
                       </a:r>
-                      <a:endParaRPr lang="en-US" sz="1500" dirty="0"/>
+                      <a:endParaRPr lang="en-US" sz="1600" dirty="0"/>
                     </a:p>
                   </a:txBody>
                   <a:tcPr marL="25400" marR="101600" marT="63500" marB="63500" anchor="ctr">
@@ -21245,14 +21245,14 @@
                         <a:buNone/>
                       </a:pPr>
                       <a:r>
-                        <a:rPr lang="en-US" sz="1500" dirty="0">
+                        <a:rPr lang="en-US" sz="1600" dirty="0">
                           <a:solidFill>
                             <a:schemeClr val="tx1"/>
                           </a:solidFill>
                         </a:rPr>
                         <a:t>KRAS (14%)</a:t>
                       </a:r>
-                      <a:endParaRPr lang="en-US" sz="1500" dirty="0"/>
+                      <a:endParaRPr lang="en-US" sz="1600" dirty="0"/>
                     </a:p>
                   </a:txBody>
                   <a:tcPr marL="25400" marR="101600" marT="63500" marB="63500" anchor="ctr">
@@ -21285,14 +21285,14 @@
                         <a:buNone/>
                       </a:pPr>
                       <a:r>
-                        <a:rPr lang="en-US" sz="1500" dirty="0">
+                        <a:rPr lang="en-US" sz="1600" dirty="0">
                           <a:solidFill>
                             <a:schemeClr val="tx1"/>
                           </a:solidFill>
                         </a:rPr>
                         <a:t>Median age 0.9 y; monosomy 7 frequent</a:t>
                       </a:r>
-                      <a:endParaRPr lang="en-US" sz="1500" dirty="0"/>
+                      <a:endParaRPr lang="en-US" sz="1600" dirty="0"/>
                     </a:p>
                   </a:txBody>
                   <a:tcPr marL="25400" marR="101600" marT="63500" marB="63500" anchor="ctr">
@@ -21325,14 +21325,14 @@
                         <a:buNone/>
                       </a:pPr>
                       <a:r>
-                        <a:rPr lang="en-US" sz="1500" dirty="0">
+                        <a:rPr lang="en-US" sz="1600" dirty="0">
                           <a:solidFill>
                             <a:schemeClr val="tx1"/>
                           </a:solidFill>
                         </a:rPr>
                         <a:t>Low or int</a:t>
                       </a:r>
-                      <a:endParaRPr lang="en-US" sz="1500" dirty="0"/>
+                      <a:endParaRPr lang="en-US" sz="1600" dirty="0"/>
                     </a:p>
                   </a:txBody>
                   <a:tcPr marL="25400" marR="101600" marT="63500" marB="63500" anchor="ctr">
@@ -21365,14 +21365,14 @@
                         <a:buNone/>
                       </a:pPr>
                       <a:r>
-                        <a:rPr lang="en-US" sz="1500" dirty="0">
+                        <a:rPr lang="en-US" sz="1600" dirty="0">
                           <a:solidFill>
                             <a:schemeClr val="tx1"/>
                           </a:solidFill>
                         </a:rPr>
                         <a:t>Most; some CR on AZA</a:t>
                       </a:r>
-                      <a:endParaRPr lang="en-US" sz="1500" dirty="0"/>
+                      <a:endParaRPr lang="en-US" sz="1600" dirty="0"/>
                     </a:p>
                   </a:txBody>
                   <a:tcPr marL="25400" marR="101600" marT="63500" marB="63500" anchor="ctr">
@@ -21407,14 +21407,14 @@
                         <a:buNone/>
                       </a:pPr>
                       <a:r>
-                        <a:rPr lang="en-US" sz="1500" dirty="0">
+                        <a:rPr lang="en-US" sz="1600" dirty="0">
                           <a:solidFill>
                             <a:schemeClr val="tx1"/>
                           </a:solidFill>
                         </a:rPr>
                         <a:t>CBL (12%)</a:t>
                       </a:r>
-                      <a:endParaRPr lang="en-US" sz="1500" dirty="0"/>
+                      <a:endParaRPr lang="en-US" sz="1600" dirty="0"/>
                     </a:p>
                   </a:txBody>
                   <a:tcPr marL="25400" marR="101600" marT="63500" marB="63500" anchor="ctr">
@@ -21447,14 +21447,14 @@
                         <a:buNone/>
                       </a:pPr>
                       <a:r>
-                        <a:rPr lang="en-US" sz="1500" dirty="0">
+                        <a:rPr lang="en-US" sz="1600" dirty="0">
                           <a:solidFill>
                             <a:schemeClr val="tx1"/>
                           </a:solidFill>
                         </a:rPr>
                         <a:t>Germline; vasculopathy risk</a:t>
                       </a:r>
-                      <a:endParaRPr lang="en-US" sz="1500" dirty="0"/>
+                      <a:endParaRPr lang="en-US" sz="1600" dirty="0"/>
                     </a:p>
                   </a:txBody>
                   <a:tcPr marL="25400" marR="101600" marT="63500" marB="63500" anchor="ctr">
@@ -21487,14 +21487,14 @@
                         <a:buNone/>
                       </a:pPr>
                       <a:r>
-                        <a:rPr lang="en-US" sz="1500" dirty="0">
+                        <a:rPr lang="en-US" sz="1600" dirty="0">
                           <a:solidFill>
                             <a:schemeClr val="tx1"/>
                           </a:solidFill>
                         </a:rPr>
                         <a:t>Generally low</a:t>
                       </a:r>
-                      <a:endParaRPr lang="en-US" sz="1500" dirty="0"/>
+                      <a:endParaRPr lang="en-US" sz="1600" dirty="0"/>
                     </a:p>
                   </a:txBody>
                   <a:tcPr marL="25400" marR="101600" marT="63500" marB="63500" anchor="ctr">
@@ -21527,14 +21527,14 @@
                         <a:buNone/>
                       </a:pPr>
                       <a:r>
-                        <a:rPr lang="en-US" sz="1500" dirty="0">
+                        <a:rPr lang="en-US" sz="1600" dirty="0">
                           <a:solidFill>
                             <a:schemeClr val="tx1"/>
                           </a:solidFill>
                         </a:rPr>
                         <a:t>Rarely required</a:t>
                       </a:r>
-                      <a:endParaRPr lang="en-US" sz="1500" dirty="0"/>
+                      <a:endParaRPr lang="en-US" sz="1600" dirty="0"/>
                     </a:p>
                   </a:txBody>
                   <a:tcPr marL="25400" marR="101600" marT="63500" marB="63500" anchor="ctr">
@@ -21571,7 +21571,7 @@
         </p:nvSpPr>
         <p:spPr>
           <a:xfrm>
-            <a:off x="685800" y="5486400"/>
+            <a:off x="685800" y="4343400"/>
             <a:ext cx="10817352" cy="411480"/>
           </a:xfrm>
           <a:prstGeom prst="rect">
@@ -21593,7 +21593,7 @@
                   <a:schemeClr val="tx1"/>
                 </a:solidFill>
               </a:rPr>
-              <a:t>Pre-HCT azacitidine; BU/CY/MEL with BM graft; relapse risk: age ≥ 2 y, HbF ≥ 15%, secondary mutations, high methylation</a:t>
+              <a:t>Pre-HCT azacitidine; BU/CY/MEL, BM graft · relapse risk: age ≥ 2 y, HbF ≥ 15%, secondary mutations, high methylation</a:t>
             </a:r>
             <a:endParaRPr lang="en-US" sz="1600" dirty="0"/>
           </a:p>
@@ -23067,14 +23067,14 @@
                         <a:buNone/>
                       </a:pPr>
                       <a:r>
-                        <a:rPr lang="en-US" sz="1500" b="1" dirty="0">
+                        <a:rPr lang="en-US" sz="1600" b="1" dirty="0">
                           <a:solidFill>
                             <a:schemeClr val="tx1"/>
                           </a:solidFill>
                         </a:rPr>
                         <a:t>Item</a:t>
                       </a:r>
-                      <a:endParaRPr lang="en-US" sz="1500" dirty="0"/>
+                      <a:endParaRPr lang="en-US" sz="1600" dirty="0"/>
                     </a:p>
                   </a:txBody>
                   <a:tcPr marL="25400" marR="101600" marT="63500" marB="63500" anchor="ctr">
@@ -23113,14 +23113,14 @@
                         <a:buNone/>
                       </a:pPr>
                       <a:r>
-                        <a:rPr lang="en-US" sz="1500" b="1" dirty="0">
+                        <a:rPr lang="en-US" sz="1600" b="1" dirty="0">
                           <a:solidFill>
                             <a:schemeClr val="tx1"/>
                           </a:solidFill>
                         </a:rPr>
                         <a:t>Chapter detail</a:t>
                       </a:r>
-                      <a:endParaRPr lang="en-US" sz="1500" dirty="0"/>
+                      <a:endParaRPr lang="en-US" sz="1600" dirty="0"/>
                     </a:p>
                   </a:txBody>
                   <a:tcPr marL="25400" marR="101600" marT="63500" marB="63500" anchor="ctr">
@@ -23161,14 +23161,14 @@
                         <a:buNone/>
                       </a:pPr>
                       <a:r>
-                        <a:rPr lang="en-US" sz="1500" dirty="0">
+                        <a:rPr lang="en-US" sz="1600" dirty="0">
                           <a:solidFill>
                             <a:schemeClr val="tx1"/>
                           </a:solidFill>
                         </a:rPr>
                         <a:t>Poor-risk cytogenetics</a:t>
                       </a:r>
-                      <a:endParaRPr lang="en-US" sz="1500" dirty="0"/>
+                      <a:endParaRPr lang="en-US" sz="1600" dirty="0"/>
                     </a:p>
                   </a:txBody>
                   <a:tcPr marL="25400" marR="101600" marT="63500" marB="63500" anchor="ctr">
@@ -23201,14 +23201,14 @@
                         <a:buNone/>
                       </a:pPr>
                       <a:r>
-                        <a:rPr lang="en-US" sz="1500" dirty="0">
+                        <a:rPr lang="en-US" sz="1600" dirty="0">
                           <a:solidFill>
                             <a:schemeClr val="tx1"/>
                           </a:solidFill>
                         </a:rPr>
                         <a:t>Poor or very poor karyotype</a:t>
                       </a:r>
-                      <a:endParaRPr lang="en-US" sz="1500" dirty="0"/>
+                      <a:endParaRPr lang="en-US" sz="1600" dirty="0"/>
                     </a:p>
                   </a:txBody>
                   <a:tcPr marL="25400" marR="101600" marT="63500" marB="63500" anchor="ctr">
@@ -23243,14 +23243,14 @@
                         <a:buNone/>
                       </a:pPr>
                       <a:r>
-                        <a:rPr lang="en-US" sz="1500" dirty="0">
+                        <a:rPr lang="en-US" sz="1600" dirty="0">
                           <a:solidFill>
                             <a:schemeClr val="tx1"/>
                           </a:solidFill>
                         </a:rPr>
                         <a:t>Persistent blast increase</a:t>
                       </a:r>
-                      <a:endParaRPr lang="en-US" sz="1500" dirty="0"/>
+                      <a:endParaRPr lang="en-US" sz="1600" dirty="0"/>
                     </a:p>
                   </a:txBody>
                   <a:tcPr marL="25400" marR="101600" marT="63500" marB="63500" anchor="ctr">
@@ -23283,14 +23283,14 @@
                         <a:buNone/>
                       </a:pPr>
                       <a:r>
-                        <a:rPr lang="en-US" sz="1500" dirty="0">
+                        <a:rPr lang="en-US" sz="1600" dirty="0">
                           <a:solidFill>
                             <a:schemeClr val="tx1"/>
                           </a:solidFill>
                         </a:rPr>
                         <a:t>Rise &gt; 50%, or &gt; 15% marrow blasts</a:t>
                       </a:r>
-                      <a:endParaRPr lang="en-US" sz="1500" dirty="0"/>
+                      <a:endParaRPr lang="en-US" sz="1600" dirty="0"/>
                     </a:p>
                   </a:txBody>
                   <a:tcPr marL="25400" marR="101600" marT="63500" marB="63500" anchor="ctr">
@@ -23325,14 +23325,14 @@
                         <a:buNone/>
                       </a:pPr>
                       <a:r>
-                        <a:rPr lang="en-US" sz="1500" dirty="0">
+                        <a:rPr lang="en-US" sz="1600" dirty="0">
                           <a:solidFill>
                             <a:schemeClr val="tx1"/>
                           </a:solidFill>
                         </a:rPr>
                         <a:t>Life-threatening cytopenias</a:t>
                       </a:r>
-                      <a:endParaRPr lang="en-US" sz="1500" dirty="0"/>
+                      <a:endParaRPr lang="en-US" sz="1600" dirty="0"/>
                     </a:p>
                   </a:txBody>
                   <a:tcPr marL="25400" marR="101600" marT="63500" marB="63500" anchor="ctr">
@@ -23365,14 +23365,14 @@
                         <a:buNone/>
                       </a:pPr>
                       <a:r>
-                        <a:rPr lang="en-US" sz="1500" dirty="0">
+                        <a:rPr lang="en-US" sz="1600" dirty="0">
                           <a:solidFill>
                             <a:schemeClr val="tx1"/>
                           </a:solidFill>
                         </a:rPr>
                         <a:t>Trigger for HCT in lower-risk MDS</a:t>
                       </a:r>
-                      <a:endParaRPr lang="en-US" sz="1500" dirty="0"/>
+                      <a:endParaRPr lang="en-US" sz="1600" dirty="0"/>
                     </a:p>
                   </a:txBody>
                   <a:tcPr marL="25400" marR="101600" marT="63500" marB="63500" anchor="ctr">
@@ -23407,14 +23407,14 @@
                         <a:buNone/>
                       </a:pPr>
                       <a:r>
-                        <a:rPr lang="en-US" sz="1500" dirty="0">
+                        <a:rPr lang="en-US" sz="1600" dirty="0">
                           <a:solidFill>
                             <a:schemeClr val="tx1"/>
                           </a:solidFill>
                         </a:rPr>
                         <a:t>High transfusion burden</a:t>
                       </a:r>
-                      <a:endParaRPr lang="en-US" sz="1500" dirty="0"/>
+                      <a:endParaRPr lang="en-US" sz="1600" dirty="0"/>
                     </a:p>
                   </a:txBody>
                   <a:tcPr marL="25400" marR="101600" marT="63500" marB="63500" anchor="ctr">
@@ -23447,14 +23447,14 @@
                         <a:buNone/>
                       </a:pPr>
                       <a:r>
-                        <a:rPr lang="en-US" sz="1500" dirty="0">
+                        <a:rPr lang="en-US" sz="1600" dirty="0">
                           <a:solidFill>
                             <a:schemeClr val="tx1"/>
                           </a:solidFill>
                         </a:rPr>
                         <a:t>&gt; 2 units per month for 6 months</a:t>
                       </a:r>
-                      <a:endParaRPr lang="en-US" sz="1500" dirty="0"/>
+                      <a:endParaRPr lang="en-US" sz="1600" dirty="0"/>
                     </a:p>
                   </a:txBody>
                   <a:tcPr marL="25400" marR="101600" marT="63500" marB="63500" anchor="ctr">
@@ -23489,14 +23489,14 @@
                         <a:buNone/>
                       </a:pPr>
                       <a:r>
-                        <a:rPr lang="en-US" sz="1500" dirty="0">
+                        <a:rPr lang="en-US" sz="1600" dirty="0">
                           <a:solidFill>
                             <a:schemeClr val="tx1"/>
                           </a:solidFill>
                         </a:rPr>
                         <a:t>No adverse karyotype or blast rise</a:t>
                       </a:r>
-                      <a:endParaRPr lang="en-US" sz="1500" dirty="0"/>
+                      <a:endParaRPr lang="en-US" sz="1600" dirty="0"/>
                     </a:p>
                   </a:txBody>
                   <a:tcPr marL="25400" marR="101600" marT="63500" marB="63500" anchor="ctr">
@@ -23529,14 +23529,14 @@
                         <a:buNone/>
                       </a:pPr>
                       <a:r>
-                        <a:rPr lang="en-US" sz="1500" dirty="0">
+                        <a:rPr lang="en-US" sz="1600" dirty="0">
                           <a:solidFill>
                             <a:schemeClr val="tx1"/>
                           </a:solidFill>
                         </a:rPr>
                         <a:t>Consider molecular testing</a:t>
                       </a:r>
-                      <a:endParaRPr lang="en-US" sz="1500" dirty="0"/>
+                      <a:endParaRPr lang="en-US" sz="1600" dirty="0"/>
                     </a:p>
                   </a:txBody>
                   <a:tcPr marL="25400" marR="101600" marT="63500" marB="63500" anchor="ctr">
@@ -23571,28 +23571,28 @@
                         <a:buNone/>
                       </a:pPr>
                       <a:r>
-                        <a:rPr lang="en-US" sz="1500" dirty="0">
+                        <a:rPr lang="en-US" sz="1600" dirty="0">
                           <a:solidFill>
                             <a:schemeClr val="tx1"/>
                           </a:solidFill>
                         </a:rPr>
                         <a:t>Robin 2015; Kröger 2021;</a:t>
                       </a:r>
-                      <a:endParaRPr lang="en-US" sz="1500" dirty="0"/>
-                    </a:p>
-                    <a:p>
-                      <a:pPr indent="0" marL="0">
-                        <a:buNone/>
-                      </a:pPr>
-                      <a:r>
-                        <a:rPr lang="en-US" sz="1500" dirty="0">
+                      <a:endParaRPr lang="en-US" sz="1600" dirty="0"/>
+                    </a:p>
+                    <a:p>
+                      <a:pPr indent="0" marL="0">
+                        <a:buNone/>
+                      </a:pPr>
+                      <a:r>
+                        <a:rPr lang="en-US" sz="1600" dirty="0">
                           <a:solidFill>
                             <a:schemeClr val="tx1"/>
                           </a:solidFill>
                         </a:rPr>
                         <a:t>Nakamura 2021</a:t>
                       </a:r>
-                      <a:endParaRPr lang="en-US" sz="1500" dirty="0"/>
+                      <a:endParaRPr lang="en-US" sz="1600" dirty="0"/>
                     </a:p>
                   </a:txBody>
                   <a:tcPr marL="25400" marR="101600" marT="63500" marB="63500" anchor="ctr">
@@ -23625,28 +23625,28 @@
                         <a:buNone/>
                       </a:pPr>
                       <a:r>
-                        <a:rPr lang="en-US" sz="1500" dirty="0">
-                          <a:solidFill>
-                            <a:schemeClr val="tx1"/>
-                          </a:solidFill>
-                        </a:rPr>
-                        <a:t>Prospective, by donor availability: HR-MDS</a:t>
-                      </a:r>
-                      <a:endParaRPr lang="en-US" sz="1500" dirty="0"/>
-                    </a:p>
-                    <a:p>
-                      <a:pPr indent="0" marL="0">
-                        <a:buNone/>
-                      </a:pPr>
-                      <a:r>
-                        <a:rPr lang="en-US" sz="1500" dirty="0">
-                          <a:solidFill>
-                            <a:schemeClr val="tx1"/>
-                          </a:solidFill>
-                        </a:rPr>
-                        <a:t>with a donor gains life expectancy</a:t>
-                      </a:r>
-                      <a:endParaRPr lang="en-US" sz="1500" dirty="0"/>
+                        <a:rPr lang="en-US" sz="1600" dirty="0">
+                          <a:solidFill>
+                            <a:schemeClr val="tx1"/>
+                          </a:solidFill>
+                        </a:rPr>
+                        <a:t>Donor-availability trials: HR-MDS</a:t>
+                      </a:r>
+                      <a:endParaRPr lang="en-US" sz="1600" dirty="0"/>
+                    </a:p>
+                    <a:p>
+                      <a:pPr indent="0" marL="0">
+                        <a:buNone/>
+                      </a:pPr>
+                      <a:r>
+                        <a:rPr lang="en-US" sz="1600" dirty="0">
+                          <a:solidFill>
+                            <a:schemeClr val="tx1"/>
+                          </a:solidFill>
+                        </a:rPr>
+                        <a:t>with a donor lives longer</a:t>
+                      </a:r>
+                      <a:endParaRPr lang="en-US" sz="1600" dirty="0"/>
                     </a:p>
                   </a:txBody>
                   <a:tcPr marL="25400" marR="101600" marT="63500" marB="63500" anchor="ctr">
@@ -23681,14 +23681,14 @@
                         <a:buNone/>
                       </a:pPr>
                       <a:r>
-                        <a:rPr lang="en-US" sz="1500" dirty="0">
+                        <a:rPr lang="en-US" sz="1600" dirty="0">
                           <a:solidFill>
                             <a:schemeClr val="tx1"/>
                           </a:solidFill>
                         </a:rPr>
                         <a:t>Cutler 2004; Koreth 2013</a:t>
                       </a:r>
-                      <a:endParaRPr lang="en-US" sz="1500" dirty="0"/>
+                      <a:endParaRPr lang="en-US" sz="1600" dirty="0"/>
                     </a:p>
                   </a:txBody>
                   <a:tcPr marL="25400" marR="101600" marT="63500" marB="63500" anchor="ctr">
@@ -23721,14 +23721,14 @@
                         <a:buNone/>
                       </a:pPr>
                       <a:r>
-                        <a:rPr lang="en-US" sz="1500" dirty="0">
+                        <a:rPr lang="en-US" sz="1600" dirty="0">
                           <a:solidFill>
                             <a:schemeClr val="tx1"/>
                           </a:solidFill>
                         </a:rPr>
                         <a:t>LR-MDS: no benefit from upfront HCT</a:t>
                       </a:r>
-                      <a:endParaRPr lang="en-US" sz="1500" dirty="0"/>
+                      <a:endParaRPr lang="en-US" sz="1600" dirty="0"/>
                     </a:p>
                   </a:txBody>
                   <a:tcPr marL="25400" marR="101600" marT="63500" marB="63500" anchor="ctr">
@@ -23763,14 +23763,14 @@
                         <a:buNone/>
                       </a:pPr>
                       <a:r>
-                        <a:rPr lang="en-US" sz="1500" dirty="0">
+                        <a:rPr lang="en-US" sz="1600" dirty="0">
                           <a:solidFill>
                             <a:schemeClr val="tx1"/>
                           </a:solidFill>
                         </a:rPr>
                         <a:t>de Witte 2017; DeFilipp 2023</a:t>
                       </a:r>
-                      <a:endParaRPr lang="en-US" sz="1500" dirty="0"/>
+                      <a:endParaRPr lang="en-US" sz="1600" dirty="0"/>
                     </a:p>
                   </a:txBody>
                   <a:tcPr marL="25400" marR="101600" marT="63500" marB="63500" anchor="ctr">
@@ -23803,28 +23803,28 @@
                         <a:buNone/>
                       </a:pPr>
                       <a:r>
-                        <a:rPr lang="en-US" sz="1500" dirty="0">
-                          <a:solidFill>
-                            <a:schemeClr val="tx1"/>
-                          </a:solidFill>
-                        </a:rPr>
-                        <a:t>HCT for HR-MDS, and LR-MDS with poor-risk</a:t>
-                      </a:r>
-                      <a:endParaRPr lang="en-US" sz="1500" dirty="0"/>
-                    </a:p>
-                    <a:p>
-                      <a:pPr indent="0" marL="0">
-                        <a:buNone/>
-                      </a:pPr>
-                      <a:r>
-                        <a:rPr lang="en-US" sz="1500" dirty="0">
-                          <a:solidFill>
-                            <a:schemeClr val="tx1"/>
-                          </a:solidFill>
-                        </a:rPr>
-                        <a:t>features or treatment failure</a:t>
-                      </a:r>
-                      <a:endParaRPr lang="en-US" sz="1500" dirty="0"/>
+                        <a:rPr lang="en-US" sz="1600" dirty="0">
+                          <a:solidFill>
+                            <a:schemeClr val="tx1"/>
+                          </a:solidFill>
+                        </a:rPr>
+                        <a:t>HCT for HR-MDS; LR-MDS with poor-risk</a:t>
+                      </a:r>
+                      <a:endParaRPr lang="en-US" sz="1600" dirty="0"/>
+                    </a:p>
+                    <a:p>
+                      <a:pPr indent="0" marL="0">
+                        <a:buNone/>
+                      </a:pPr>
+                      <a:r>
+                        <a:rPr lang="en-US" sz="1600" dirty="0">
+                          <a:solidFill>
+                            <a:schemeClr val="tx1"/>
+                          </a:solidFill>
+                        </a:rPr>
+                        <a:t>features or failed therapy</a:t>
+                      </a:r>
+                      <a:endParaRPr lang="en-US" sz="1600" dirty="0"/>
                     </a:p>
                   </a:txBody>
                   <a:tcPr marL="25400" marR="101600" marT="63500" marB="63500" anchor="ctr">
@@ -26375,7 +26375,7 @@
                             <a:schemeClr val="tx1"/>
                           </a:solidFill>
                         </a:rPr>
-                        <a:t>Low/int DRI: lower DFS with RIC</a:t>
+                        <a:t>Low/int DRI: RIC lower DFS (HR 1.19);</a:t>
                       </a:r>
                       <a:endParaRPr lang="en-US" sz="1700" dirty="0"/>
                     </a:p>
@@ -26389,7 +26389,7 @@
                             <a:schemeClr val="tx1"/>
                           </a:solidFill>
                         </a:rPr>
-                        <a:t>(HR 1.19); high/very high: similar</a:t>
+                        <a:t>high/very high: similar</a:t>
                       </a:r>
                       <a:endParaRPr lang="en-US" sz="1700" dirty="0"/>
                     </a:p>
@@ -26812,14 +26812,14 @@
                         <a:buNone/>
                       </a:pPr>
                       <a:r>
-                        <a:rPr lang="en-US" sz="1500" b="1" dirty="0">
+                        <a:rPr lang="en-US" sz="1600" b="1" dirty="0">
                           <a:solidFill>
                             <a:schemeClr val="tx1"/>
                           </a:solidFill>
                         </a:rPr>
                         <a:t>Domain</a:t>
                       </a:r>
-                      <a:endParaRPr lang="en-US" sz="1500" dirty="0"/>
+                      <a:endParaRPr lang="en-US" sz="1600" dirty="0"/>
                     </a:p>
                   </a:txBody>
                   <a:tcPr marL="25400" marR="101600" marT="63500" marB="63500" anchor="ctr">
@@ -26858,14 +26858,14 @@
                         <a:buNone/>
                       </a:pPr>
                       <a:r>
-                        <a:rPr lang="en-US" sz="1500" b="1" dirty="0">
+                        <a:rPr lang="en-US" sz="1600" b="1" dirty="0">
                           <a:solidFill>
                             <a:schemeClr val="tx1"/>
                           </a:solidFill>
                         </a:rPr>
                         <a:t>Finding (Ch. 74)</a:t>
                       </a:r>
-                      <a:endParaRPr lang="en-US" sz="1500" dirty="0"/>
+                      <a:endParaRPr lang="en-US" sz="1600" dirty="0"/>
                     </a:p>
                   </a:txBody>
                   <a:tcPr marL="25400" marR="101600" marT="63500" marB="63500" anchor="ctr">
@@ -26906,14 +26906,14 @@
                         <a:buNone/>
                       </a:pPr>
                       <a:r>
-                        <a:rPr lang="en-US" sz="1500" dirty="0">
+                        <a:rPr lang="en-US" sz="1600" dirty="0">
                           <a:solidFill>
                             <a:schemeClr val="tx1"/>
                           </a:solidFill>
                         </a:rPr>
                         <a:t>Disease</a:t>
                       </a:r>
-                      <a:endParaRPr lang="en-US" sz="1500" dirty="0"/>
+                      <a:endParaRPr lang="en-US" sz="1600" dirty="0"/>
                     </a:p>
                   </a:txBody>
                   <a:tcPr marL="25400" marR="101600" marT="63500" marB="63500" anchor="ctr">
@@ -26946,14 +26946,14 @@
                         <a:buNone/>
                       </a:pPr>
                       <a:r>
-                        <a:rPr lang="en-US" sz="1500" dirty="0">
+                        <a:rPr lang="en-US" sz="1600" dirty="0">
                           <a:solidFill>
                             <a:schemeClr val="tx1"/>
                           </a:solidFill>
                         </a:rPr>
                         <a:t>Poor/very poor karyotype incl. monosomal; HR-MDS</a:t>
                       </a:r>
-                      <a:endParaRPr lang="en-US" sz="1500" dirty="0"/>
+                      <a:endParaRPr lang="en-US" sz="1600" dirty="0"/>
                     </a:p>
                   </a:txBody>
                   <a:tcPr marL="25400" marR="101600" marT="63500" marB="63500" anchor="ctr">
@@ -26988,14 +26988,14 @@
                         <a:buNone/>
                       </a:pPr>
                       <a:r>
-                        <a:rPr lang="en-US" sz="1500" dirty="0">
+                        <a:rPr lang="en-US" sz="1600" dirty="0">
                           <a:solidFill>
                             <a:schemeClr val="tx1"/>
                           </a:solidFill>
                         </a:rPr>
                         <a:t>Mutations (Lindsley 2017)</a:t>
                       </a:r>
-                      <a:endParaRPr lang="en-US" sz="1500" dirty="0"/>
+                      <a:endParaRPr lang="en-US" sz="1600" dirty="0"/>
                     </a:p>
                   </a:txBody>
                   <a:tcPr marL="25400" marR="101600" marT="63500" marB="63500" anchor="ctr">
@@ -27028,14 +27028,14 @@
                         <a:buNone/>
                       </a:pPr>
                       <a:r>
-                        <a:rPr lang="en-US" sz="1500" dirty="0">
+                        <a:rPr lang="en-US" sz="1600" dirty="0">
                           <a:solidFill>
                             <a:schemeClr val="tx1"/>
                           </a:solidFill>
                         </a:rPr>
                         <a:t>Biallelic TP53, ASXL1, RUNX1, RAS pathway</a:t>
                       </a:r>
-                      <a:endParaRPr lang="en-US" sz="1500" dirty="0"/>
+                      <a:endParaRPr lang="en-US" sz="1600" dirty="0"/>
                     </a:p>
                   </a:txBody>
                   <a:tcPr marL="25400" marR="101600" marT="63500" marB="63500" anchor="ctr">
@@ -27070,14 +27070,14 @@
                         <a:buNone/>
                       </a:pPr>
                       <a:r>
-                        <a:rPr lang="en-US" sz="1500" dirty="0">
+                        <a:rPr lang="en-US" sz="1600" dirty="0">
                           <a:solidFill>
                             <a:schemeClr val="tx1"/>
                           </a:solidFill>
                         </a:rPr>
                         <a:t>Patient</a:t>
                       </a:r>
-                      <a:endParaRPr lang="en-US" sz="1500" dirty="0"/>
+                      <a:endParaRPr lang="en-US" sz="1600" dirty="0"/>
                     </a:p>
                   </a:txBody>
                   <a:tcPr marL="25400" marR="101600" marT="63500" marB="63500" anchor="ctr">
@@ -27110,14 +27110,14 @@
                         <a:buNone/>
                       </a:pPr>
                       <a:r>
-                        <a:rPr lang="en-US" sz="1500" dirty="0">
+                        <a:rPr lang="en-US" sz="1600" dirty="0">
                           <a:solidFill>
                             <a:schemeClr val="tx1"/>
                           </a:solidFill>
                         </a:rPr>
                         <a:t>Age; HCT-CI</a:t>
                       </a:r>
-                      <a:endParaRPr lang="en-US" sz="1500" dirty="0"/>
+                      <a:endParaRPr lang="en-US" sz="1600" dirty="0"/>
                     </a:p>
                   </a:txBody>
                   <a:tcPr marL="25400" marR="101600" marT="63500" marB="63500" anchor="ctr">
@@ -27152,14 +27152,14 @@
                         <a:buNone/>
                       </a:pPr>
                       <a:r>
-                        <a:rPr lang="en-US" sz="1500" dirty="0">
+                        <a:rPr lang="en-US" sz="1600" dirty="0">
                           <a:solidFill>
                             <a:schemeClr val="tx1"/>
                           </a:solidFill>
                         </a:rPr>
                         <a:t>EBMT score (Gagelmann 2019)</a:t>
                       </a:r>
-                      <a:endParaRPr lang="en-US" sz="1500" dirty="0"/>
+                      <a:endParaRPr lang="en-US" sz="1600" dirty="0"/>
                     </a:p>
                   </a:txBody>
                   <a:tcPr marL="25400" marR="101600" marT="63500" marB="63500" anchor="ctr">
@@ -27192,28 +27192,28 @@
                         <a:buNone/>
                       </a:pPr>
                       <a:r>
-                        <a:rPr lang="en-US" sz="1500" dirty="0">
+                        <a:rPr lang="en-US" sz="1600" dirty="0">
                           <a:solidFill>
                             <a:schemeClr val="tx1"/>
                           </a:solidFill>
                         </a:rPr>
                         <a:t>Age, donor, PS, karyotype, recipient CMV,</a:t>
                       </a:r>
-                      <a:endParaRPr lang="en-US" sz="1500" dirty="0"/>
-                    </a:p>
-                    <a:p>
-                      <a:pPr indent="0" marL="0">
-                        <a:buNone/>
-                      </a:pPr>
-                      <a:r>
-                        <a:rPr lang="en-US" sz="1500" dirty="0">
+                      <a:endParaRPr lang="en-US" sz="1600" dirty="0"/>
+                    </a:p>
+                    <a:p>
+                      <a:pPr indent="0" marL="0">
+                        <a:buNone/>
+                      </a:pPr>
+                      <a:r>
+                        <a:rPr lang="en-US" sz="1600" dirty="0">
                           <a:solidFill>
                             <a:schemeClr val="tx1"/>
                           </a:solidFill>
                         </a:rPr>
                         <a:t>blasts, platelets</a:t>
                       </a:r>
-                      <a:endParaRPr lang="en-US" sz="1500" dirty="0"/>
+                      <a:endParaRPr lang="en-US" sz="1600" dirty="0"/>
                     </a:p>
                   </a:txBody>
                   <a:tcPr marL="25400" marR="101600" marT="63500" marB="63500" anchor="ctr">
@@ -27248,14 +27248,14 @@
                         <a:buNone/>
                       </a:pPr>
                       <a:r>
-                        <a:rPr lang="en-US" sz="1500" dirty="0">
+                        <a:rPr lang="en-US" sz="1600" dirty="0">
                           <a:solidFill>
                             <a:schemeClr val="tx1"/>
                           </a:solidFill>
                         </a:rPr>
                         <a:t>MSD or MUD</a:t>
                       </a:r>
-                      <a:endParaRPr lang="en-US" sz="1500" dirty="0"/>
+                      <a:endParaRPr lang="en-US" sz="1600" dirty="0"/>
                     </a:p>
                   </a:txBody>
                   <a:tcPr marL="25400" marR="101600" marT="63500" marB="63500" anchor="ctr">
@@ -27288,14 +27288,14 @@
                         <a:buNone/>
                       </a:pPr>
                       <a:r>
-                        <a:rPr lang="en-US" sz="1500" dirty="0">
+                        <a:rPr lang="en-US" sz="1600" dirty="0">
                           <a:solidFill>
                             <a:schemeClr val="tx1"/>
                           </a:solidFill>
                         </a:rPr>
                         <a:t>Both suitable options</a:t>
                       </a:r>
-                      <a:endParaRPr lang="en-US" sz="1500" dirty="0"/>
+                      <a:endParaRPr lang="en-US" sz="1600" dirty="0"/>
                     </a:p>
                   </a:txBody>
                   <a:tcPr marL="25400" marR="101600" marT="63500" marB="63500" anchor="ctr">
@@ -27330,14 +27330,14 @@
                         <a:buNone/>
                       </a:pPr>
                       <a:r>
-                        <a:rPr lang="en-US" sz="1500" dirty="0">
+                        <a:rPr lang="en-US" sz="1600" dirty="0">
                           <a:solidFill>
                             <a:schemeClr val="tx1"/>
                           </a:solidFill>
                         </a:rPr>
                         <a:t>Haploidentical</a:t>
                       </a:r>
-                      <a:endParaRPr lang="en-US" sz="1500" dirty="0"/>
+                      <a:endParaRPr lang="en-US" sz="1600" dirty="0"/>
                     </a:p>
                   </a:txBody>
                   <a:tcPr marL="25400" marR="101600" marT="63500" marB="63500" anchor="ctr">
@@ -27370,14 +27370,14 @@
                         <a:buNone/>
                       </a:pPr>
                       <a:r>
-                        <a:rPr lang="en-US" sz="1500" dirty="0">
+                        <a:rPr lang="en-US" sz="1600" dirty="0">
                           <a:solidFill>
                             <a:schemeClr val="tx1"/>
                           </a:solidFill>
                         </a:rPr>
                         <a:t>Promising, but excess NRM vs matched donors</a:t>
                       </a:r>
-                      <a:endParaRPr lang="en-US" sz="1500" dirty="0"/>
+                      <a:endParaRPr lang="en-US" sz="1600" dirty="0"/>
                     </a:p>
                   </a:txBody>
                   <a:tcPr marL="25400" marR="101600" marT="63500" marB="63500" anchor="ctr">
@@ -27412,14 +27412,14 @@
                         <a:buNone/>
                       </a:pPr>
                       <a:r>
-                        <a:rPr lang="en-US" sz="1500" dirty="0">
+                        <a:rPr lang="en-US" sz="1600" dirty="0">
                           <a:solidFill>
                             <a:schemeClr val="tx1"/>
                           </a:solidFill>
                         </a:rPr>
                         <a:t>Cord blood</a:t>
                       </a:r>
-                      <a:endParaRPr lang="en-US" sz="1500" dirty="0"/>
+                      <a:endParaRPr lang="en-US" sz="1600" dirty="0"/>
                     </a:p>
                   </a:txBody>
                   <a:tcPr marL="25400" marR="101600" marT="63500" marB="63500" anchor="ctr">
@@ -27452,14 +27452,14 @@
                         <a:buNone/>
                       </a:pPr>
                       <a:r>
-                        <a:rPr lang="en-US" sz="1500" dirty="0">
+                        <a:rPr lang="en-US" sz="1600" dirty="0">
                           <a:solidFill>
                             <a:schemeClr val="tx1"/>
                           </a:solidFill>
                         </a:rPr>
                         <a:t>Less used: low cell dose, slow recovery</a:t>
                       </a:r>
-                      <a:endParaRPr lang="en-US" sz="1500" dirty="0"/>
+                      <a:endParaRPr lang="en-US" sz="1600" dirty="0"/>
                     </a:p>
                   </a:txBody>
                   <a:tcPr marL="25400" marR="101600" marT="63500" marB="63500" anchor="ctr">
@@ -27494,28 +27494,28 @@
                         <a:buNone/>
                       </a:pPr>
                       <a:r>
-                        <a:rPr lang="en-US" sz="1500" dirty="0">
+                        <a:rPr lang="en-US" sz="1600" dirty="0">
                           <a:solidFill>
                             <a:schemeClr val="tx1"/>
                           </a:solidFill>
                         </a:rPr>
                         <a:t>Donor age (Kröger 2013;</a:t>
                       </a:r>
-                      <a:endParaRPr lang="en-US" sz="1500" dirty="0"/>
-                    </a:p>
-                    <a:p>
-                      <a:pPr indent="0" marL="0">
-                        <a:buNone/>
-                      </a:pPr>
-                      <a:r>
-                        <a:rPr lang="en-US" sz="1500" dirty="0">
+                      <a:endParaRPr lang="en-US" sz="1600" dirty="0"/>
+                    </a:p>
+                    <a:p>
+                      <a:pPr indent="0" marL="0">
+                        <a:buNone/>
+                      </a:pPr>
+                      <a:r>
+                        <a:rPr lang="en-US" sz="1600" dirty="0">
                           <a:solidFill>
                             <a:schemeClr val="tx1"/>
                           </a:solidFill>
                         </a:rPr>
                         <a:t>Murthy 2022)</a:t>
                       </a:r>
-                      <a:endParaRPr lang="en-US" sz="1500" dirty="0"/>
+                      <a:endParaRPr lang="en-US" sz="1600" dirty="0"/>
                     </a:p>
                   </a:txBody>
                   <a:tcPr marL="25400" marR="101600" marT="63500" marB="63500" anchor="ctr">
@@ -27548,14 +27548,14 @@
                         <a:buNone/>
                       </a:pPr>
                       <a:r>
-                        <a:rPr lang="en-US" sz="1500" dirty="0">
+                        <a:rPr lang="en-US" sz="1600" dirty="0">
                           <a:solidFill>
                             <a:schemeClr val="tx1"/>
                           </a:solidFill>
                         </a:rPr>
                         <a:t>Younger donors preferred</a:t>
                       </a:r>
-                      <a:endParaRPr lang="en-US" sz="1500" dirty="0"/>
+                      <a:endParaRPr lang="en-US" sz="1600" dirty="0"/>
                     </a:p>
                   </a:txBody>
                   <a:tcPr marL="25400" marR="101600" marT="63500" marB="63500" anchor="ctr">

</xml_diff>

<commit_message>
Slides: session 06 transfusion and ABO; others in progress
Co-Authored-By: Claude Opus 5.5 <noreply@anthropic.com>
Claude-Session: https://claude.ai/code/session_01XkzKv8pUGMF9AsqSCMpnBq
</commit_message>
<xml_diff>
--- a/slides/decks/s23-mds-mds-mpn.pptx
+++ b/slides/decks/s23-mds-mds-mpn.pptx
@@ -136,13 +136,13 @@
   <p:extLst>
     <p:ext uri="{521415D9-36F7-43E2-AB2F-B90AF26B5E84}">
       <p14:sectionLst xmlns:p14="http://schemas.microsoft.com/office/powerpoint/2010/main">
-        <p14:section name="Opening" id="{48787dfc-26b5-cc16-bc63-c68119666c6b}">
+        <p14:section name="Opening" id="{41916fdd-1f2a-8ce1-6e17-a2d0f1cb14e3}">
           <p14:sldIdLst>
             <p14:sldId id="256"/>
             <p14:sldId id="257"/>
           </p14:sldIdLst>
         </p14:section>
-        <p14:section name="MDS" id="{3e84ab46-4e17-5d74-a141-d6779d875a3f}">
+        <p14:section name="MDS" id="{0777c5d5-014b-4e5e-d637-7655e722a0c1}">
           <p14:sldIdLst>
             <p14:sldId id="258"/>
             <p14:sldId id="259"/>
@@ -154,7 +154,7 @@
             <p14:sldId id="265"/>
           </p14:sldIdLst>
         </p14:section>
-        <p14:section name="MDS/MPN" id="{5096424e-f03f-1c24-823c-bc92aa706090}">
+        <p14:section name="MDS/MPN" id="{7f5934f0-0ae4-2741-167e-bf3af4b54466}">
           <p14:sldIdLst>
             <p14:sldId id="266"/>
             <p14:sldId id="267"/>
@@ -164,7 +164,7 @@
             <p14:sldId id="271"/>
           </p14:sldIdLst>
         </p14:section>
-        <p14:section name="Board questions" id="{19f1ce95-98bd-14ea-b2d9-e19c950560f0}">
+        <p14:section name="Board questions" id="{dde73cf9-0fa7-860a-220b-35897606e373}">
           <p14:sldIdLst>
             <p14:sldId id="272"/>
             <p14:sldId id="273"/>
@@ -174,7 +174,7 @@
             <p14:sldId id="277"/>
           </p14:sldIdLst>
         </p14:section>
-        <p14:section name="References" id="{513a3a7e-541c-bf96-ce85-2d868fd9c486}">
+        <p14:section name="References" id="{5e25547b-69c4-f5e1-63ce-49e891059437}">
           <p14:sldIdLst>
             <p14:sldId id="278"/>
             <p14:sldId id="279"/>
@@ -183,7 +183,7 @@
             <p14:sldId id="282"/>
           </p14:sldIdLst>
         </p14:section>
-        <p14:section name="Backup" id="{351db643-c156-c94b-a4d8-f670e6a93ae3}">
+        <p14:section name="Backup" id="{0ee0a192-5fce-b4b2-459c-6047f9f44f4b}">
           <p14:sldIdLst>
             <p14:sldId id="283"/>
             <p14:sldId id="284"/>

</xml_diff>